<commit_message>
Refine presentation design for vocational school
Co-authored-by: tom948899-jpg <300044775+tom948899-jpg@users.noreply.github.com>
</commit_message>
<xml_diff>
--- a/Leuchtstofflampen_Praesentation.pptx
+++ b/Leuchtstofflampen_Praesentation.pptx
@@ -3093,7 +3093,7 @@
     <p:bg>
       <p:bgPr>
         <a:solidFill>
-          <a:srgbClr val="070F20"/>
+          <a:srgbClr val="0E192B"/>
         </a:solidFill>
         <a:effectLst/>
       </p:bgPr>
@@ -3107,7 +3107,7 @@
       <p:grpSpPr/>
       <p:pic>
         <p:nvPicPr>
-          <p:cNvPr id="2" name="Picture 1" descr="title.png"/>
+          <p:cNvPr id="2" name="Picture 1" descr="title_scene.png"/>
           <p:cNvPicPr>
             <a:picLocks noChangeAspect="1"/>
           </p:cNvPicPr>
@@ -3137,8 +3137,8 @@
         </p:nvSpPr>
         <p:spPr>
           <a:xfrm>
-            <a:off x="640080" y="6172200"/>
-            <a:ext cx="4572000" cy="365760"/>
+            <a:off x="749808" y="6291072"/>
+            <a:ext cx="3931920" cy="228600"/>
           </a:xfrm>
           <a:prstGeom prst="rect">
             <a:avLst/>
@@ -3146,16 +3146,20 @@
           <a:noFill/>
         </p:spPr>
         <p:txBody>
-          <a:bodyPr wrap="none">
+          <a:bodyPr wrap="square" anchor="t">
             <a:spAutoFit/>
           </a:bodyPr>
           <a:lstStyle/>
           <a:p>
-            <a:pPr>
-              <a:defRPr sz="1200">
-                <a:solidFill>
-                  <a:srgbClr val="C8DCEB"/>
-                </a:solidFill>
+            <a:pPr algn="l">
+              <a:lnSpc>
+                <a:spcPct val="120000"/>
+              </a:lnSpc>
+              <a:defRPr sz="1100" b="0">
+                <a:solidFill>
+                  <a:srgbClr val="CEDCE8"/>
+                </a:solidFill>
+                <a:latin typeface="Aptos"/>
               </a:defRPr>
             </a:pPr>
             <a:r>
@@ -3178,7 +3182,7 @@
     <p:bg>
       <p:bgPr>
         <a:solidFill>
-          <a:srgbClr val="091527"/>
+          <a:srgbClr val="0A1627"/>
         </a:solidFill>
         <a:effectLst/>
       </p:bgPr>
@@ -3198,8 +3202,8 @@
         </p:nvSpPr>
         <p:spPr>
           <a:xfrm>
-            <a:off x="594360" y="320040"/>
-            <a:ext cx="8046720" cy="822960"/>
+            <a:off x="640080" y="411480"/>
+            <a:ext cx="9601200" cy="548640"/>
           </a:xfrm>
           <a:prstGeom prst="rect">
             <a:avLst/>
@@ -3207,18 +3211,23 @@
           <a:noFill/>
         </p:spPr>
         <p:txBody>
-          <a:bodyPr wrap="none">
+          <a:bodyPr wrap="square" anchor="t">
             <a:spAutoFit/>
           </a:bodyPr>
           <a:lstStyle/>
           <a:p>
-            <a:r>
-              <a:rPr b="1" sz="2500">
+            <a:pPr algn="l">
+              <a:lnSpc>
+                <a:spcPct val="120000"/>
+              </a:lnSpc>
+              <a:defRPr sz="2500" b="1">
                 <a:solidFill>
                   <a:srgbClr val="FFFFFF"/>
                 </a:solidFill>
                 <a:latin typeface="Aptos Display"/>
-              </a:rPr>
+              </a:defRPr>
+            </a:pPr>
+            <a:r>
               <a:t>Fazit</a:t>
             </a:r>
           </a:p>
@@ -3232,8 +3241,8 @@
         </p:nvSpPr>
         <p:spPr>
           <a:xfrm>
-            <a:off x="621792" y="914400"/>
-            <a:ext cx="7315200" cy="411480"/>
+            <a:off x="658368" y="868680"/>
+            <a:ext cx="9875520" cy="320040"/>
           </a:xfrm>
           <a:prstGeom prst="rect">
             <a:avLst/>
@@ -3241,18 +3250,24 @@
           <a:noFill/>
         </p:spPr>
         <p:txBody>
-          <a:bodyPr wrap="none">
+          <a:bodyPr wrap="square" anchor="t">
             <a:spAutoFit/>
           </a:bodyPr>
           <a:lstStyle/>
           <a:p>
-            <a:r>
-              <a:rPr sz="1200">
-                <a:solidFill>
-                  <a:srgbClr val="D7E8F5"/>
-                </a:solidFill>
-              </a:rPr>
-              <a:t>Technisch bedeutsam, heute aber meist von LEDs ersetzt</a:t>
+            <a:pPr algn="l">
+              <a:lnSpc>
+                <a:spcPct val="120000"/>
+              </a:lnSpc>
+              <a:defRPr sz="1200" b="0">
+                <a:solidFill>
+                  <a:srgbClr val="D6E3ED"/>
+                </a:solidFill>
+                <a:latin typeface="Aptos"/>
+              </a:defRPr>
+            </a:pPr>
+            <a:r>
+              <a:t>Kurz und verständlich zusammengefasst</a:t>
             </a:r>
           </a:p>
         </p:txBody>
@@ -3265,8 +3280,8 @@
         </p:nvSpPr>
         <p:spPr>
           <a:xfrm>
-            <a:off x="822960" y="1554480"/>
-            <a:ext cx="10972800" cy="914400"/>
+            <a:off x="914400" y="1508760"/>
+            <a:ext cx="10332720" cy="731520"/>
           </a:xfrm>
           <a:prstGeom prst="rect">
             <a:avLst/>
@@ -3274,20 +3289,40 @@
           <a:noFill/>
         </p:spPr>
         <p:txBody>
-          <a:bodyPr wrap="none">
+          <a:bodyPr wrap="square" anchor="t">
             <a:spAutoFit/>
           </a:bodyPr>
           <a:lstStyle/>
           <a:p>
             <a:pPr algn="ctr">
-              <a:defRPr sz="2400" b="1">
-                <a:solidFill>
-                  <a:srgbClr val="FFFFFF"/>
-                </a:solidFill>
+              <a:lnSpc>
+                <a:spcPct val="120000"/>
+              </a:lnSpc>
+              <a:defRPr sz="2200" b="0">
+                <a:solidFill>
+                  <a:srgbClr val="F1F6FA"/>
+                </a:solidFill>
+                <a:latin typeface="Aptos"/>
               </a:defRPr>
             </a:pPr>
             <a:r>
-              <a:t>Leuchtstofflampen waren ein wichtiger Schritt zu effizienter Beleuchtung – ihre Zukunft gehört jedoch meist der LED.</a:t>
+              <a:t>Leuchtstofflampen waren über viele Jahre die Standardlösung für große Innenräume.</a:t>
+            </a:r>
+          </a:p>
+          <a:p>
+            <a:pPr>
+              <a:lnSpc>
+                <a:spcPct val="120000"/>
+              </a:lnSpc>
+              <a:defRPr sz="2200" b="0">
+                <a:solidFill>
+                  <a:srgbClr val="F1F6FA"/>
+                </a:solidFill>
+                <a:latin typeface="Aptos"/>
+              </a:defRPr>
+            </a:pPr>
+            <a:r>
+              <a:t>Technisch sind sie interessant, heute werden sie jedoch meist durch LED-Systeme ersetzt.</a:t>
             </a:r>
           </a:p>
         </p:txBody>
@@ -3300,7 +3335,7 @@
         </p:nvSpPr>
         <p:spPr>
           <a:xfrm>
-            <a:off x="777240" y="2743200"/>
+            <a:off x="822960" y="2880360"/>
             <a:ext cx="3246120" cy="2011680"/>
           </a:xfrm>
           <a:prstGeom prst="roundRect">
@@ -3311,7 +3346,7 @@
           </a:solidFill>
           <a:ln>
             <a:solidFill>
-              <a:srgbClr val="4EAADE"/>
+              <a:srgbClr val="57B8E8"/>
             </a:solidFill>
           </a:ln>
         </p:spPr>
@@ -3345,8 +3380,8 @@
         </p:nvSpPr>
         <p:spPr>
           <a:xfrm>
-            <a:off x="960120" y="2926080"/>
-            <a:ext cx="2834640" cy="1554480"/>
+            <a:off x="987552" y="3108960"/>
+            <a:ext cx="2834640" cy="292608"/>
           </a:xfrm>
           <a:prstGeom prst="rect">
             <a:avLst/>
@@ -3354,48 +3389,76 @@
           <a:noFill/>
         </p:spPr>
         <p:txBody>
-          <a:bodyPr wrap="none">
+          <a:bodyPr wrap="square" anchor="t">
             <a:spAutoFit/>
           </a:bodyPr>
           <a:lstStyle/>
           <a:p>
-            <a:pPr>
-              <a:defRPr sz="2100" b="1">
-                <a:solidFill>
-                  <a:srgbClr val="54CFFF"/>
-                </a:solidFill>
+            <a:pPr algn="l">
+              <a:lnSpc>
+                <a:spcPct val="120000"/>
+              </a:lnSpc>
+              <a:defRPr sz="1900" b="1">
+                <a:solidFill>
+                  <a:srgbClr val="57D6FF"/>
+                </a:solidFill>
+                <a:latin typeface="Aptos"/>
               </a:defRPr>
             </a:pPr>
             <a:r>
-              <a:t>Technik</a:t>
-            </a:r>
-          </a:p>
-          <a:p>
-            <a:pPr>
-              <a:spcBef>
-                <a:spcPts val="800"/>
-              </a:spcBef>
-              <a:defRPr sz="1500">
+              <a:t>Aufbau</a:t>
+            </a:r>
+          </a:p>
+        </p:txBody>
+      </p:sp>
+      <p:sp>
+        <p:nvSpPr>
+          <p:cNvPr id="7" name="TextBox 6"/>
+          <p:cNvSpPr txBox="1"/>
+          <p:nvPr/>
+        </p:nvSpPr>
+        <p:spPr>
+          <a:xfrm>
+            <a:off x="987552" y="3493008"/>
+            <a:ext cx="2880360" cy="1005840"/>
+          </a:xfrm>
+          <a:prstGeom prst="rect">
+            <a:avLst/>
+          </a:prstGeom>
+          <a:noFill/>
+        </p:spPr>
+        <p:txBody>
+          <a:bodyPr wrap="square" anchor="t">
+            <a:spAutoFit/>
+          </a:bodyPr>
+          <a:lstStyle/>
+          <a:p>
+            <a:pPr algn="l">
+              <a:lnSpc>
+                <a:spcPct val="120000"/>
+              </a:lnSpc>
+              <a:defRPr sz="1400" b="0">
                 <a:solidFill>
                   <a:srgbClr val="E2ECF4"/>
                 </a:solidFill>
+                <a:latin typeface="Aptos"/>
               </a:defRPr>
             </a:pPr>
             <a:r>
-              <a:t>Gasentladung + Leuchtstoffschicht erzeugen sichtbares Licht.</a:t>
-            </a:r>
-          </a:p>
-        </p:txBody>
-      </p:sp>
-      <p:sp>
-        <p:nvSpPr>
-          <p:cNvPr id="7" name="Rounded Rectangle 6"/>
+              <a:t>Gasfüllung, Elektroden, Leuchtstoffschicht und Vorschaltgerät arbeiten zusammen.</a:t>
+            </a:r>
+          </a:p>
+        </p:txBody>
+      </p:sp>
+      <p:sp>
+        <p:nvSpPr>
+          <p:cNvPr id="8" name="Rounded Rectangle 7"/>
           <p:cNvSpPr/>
           <p:nvPr/>
         </p:nvSpPr>
         <p:spPr>
           <a:xfrm>
-            <a:off x="4480559" y="2743200"/>
+            <a:off x="4572000" y="2880360"/>
             <a:ext cx="3246120" cy="2011680"/>
           </a:xfrm>
           <a:prstGeom prst="roundRect">
@@ -3406,7 +3469,7 @@
           </a:solidFill>
           <a:ln>
             <a:solidFill>
-              <a:srgbClr val="4EAADE"/>
+              <a:srgbClr val="57B8E8"/>
             </a:solidFill>
           </a:ln>
         </p:spPr>
@@ -3434,14 +3497,14 @@
       </p:sp>
       <p:sp>
         <p:nvSpPr>
-          <p:cNvPr id="8" name="TextBox 7"/>
+          <p:cNvPr id="9" name="TextBox 8"/>
           <p:cNvSpPr txBox="1"/>
           <p:nvPr/>
         </p:nvSpPr>
         <p:spPr>
           <a:xfrm>
-            <a:off x="4663439" y="2926080"/>
-            <a:ext cx="2834640" cy="1554480"/>
+            <a:off x="4736592" y="3108960"/>
+            <a:ext cx="2834640" cy="292608"/>
           </a:xfrm>
           <a:prstGeom prst="rect">
             <a:avLst/>
@@ -3449,48 +3512,76 @@
           <a:noFill/>
         </p:spPr>
         <p:txBody>
-          <a:bodyPr wrap="none">
+          <a:bodyPr wrap="square" anchor="t">
             <a:spAutoFit/>
           </a:bodyPr>
           <a:lstStyle/>
           <a:p>
-            <a:pPr>
-              <a:defRPr sz="2100" b="1">
-                <a:solidFill>
-                  <a:srgbClr val="54CFFF"/>
-                </a:solidFill>
+            <a:pPr algn="l">
+              <a:lnSpc>
+                <a:spcPct val="120000"/>
+              </a:lnSpc>
+              <a:defRPr sz="1900" b="1">
+                <a:solidFill>
+                  <a:srgbClr val="57D6FF"/>
+                </a:solidFill>
+                <a:latin typeface="Aptos"/>
               </a:defRPr>
             </a:pPr>
             <a:r>
               <a:t>Praxis</a:t>
             </a:r>
           </a:p>
-          <a:p>
-            <a:pPr>
-              <a:spcBef>
-                <a:spcPts val="800"/>
-              </a:spcBef>
-              <a:defRPr sz="1500">
+        </p:txBody>
+      </p:sp>
+      <p:sp>
+        <p:nvSpPr>
+          <p:cNvPr id="10" name="TextBox 9"/>
+          <p:cNvSpPr txBox="1"/>
+          <p:nvPr/>
+        </p:nvSpPr>
+        <p:spPr>
+          <a:xfrm>
+            <a:off x="4736592" y="3493008"/>
+            <a:ext cx="2880360" cy="1005840"/>
+          </a:xfrm>
+          <a:prstGeom prst="rect">
+            <a:avLst/>
+          </a:prstGeom>
+          <a:noFill/>
+        </p:spPr>
+        <p:txBody>
+          <a:bodyPr wrap="square" anchor="t">
+            <a:spAutoFit/>
+          </a:bodyPr>
+          <a:lstStyle/>
+          <a:p>
+            <a:pPr algn="l">
+              <a:lnSpc>
+                <a:spcPct val="120000"/>
+              </a:lnSpc>
+              <a:defRPr sz="1400" b="0">
                 <a:solidFill>
                   <a:srgbClr val="E2ECF4"/>
                 </a:solidFill>
+                <a:latin typeface="Aptos"/>
               </a:defRPr>
             </a:pPr>
             <a:r>
-              <a:t>Geeignet für große Räume mit gleichmäßiger Ausleuchtung.</a:t>
-            </a:r>
-          </a:p>
-        </p:txBody>
-      </p:sp>
-      <p:sp>
-        <p:nvSpPr>
-          <p:cNvPr id="9" name="Rounded Rectangle 8"/>
+              <a:t>Besonders geeignet bei längeren Brennzeiten und gleichmäßiger Raumausleuchtung.</a:t>
+            </a:r>
+          </a:p>
+        </p:txBody>
+      </p:sp>
+      <p:sp>
+        <p:nvSpPr>
+          <p:cNvPr id="11" name="Rounded Rectangle 10"/>
           <p:cNvSpPr/>
           <p:nvPr/>
         </p:nvSpPr>
         <p:spPr>
           <a:xfrm>
-            <a:off x="8183879" y="2743200"/>
+            <a:off x="8321040" y="2880360"/>
             <a:ext cx="3246120" cy="2011680"/>
           </a:xfrm>
           <a:prstGeom prst="roundRect">
@@ -3501,7 +3592,7 @@
           </a:solidFill>
           <a:ln>
             <a:solidFill>
-              <a:srgbClr val="4EAADE"/>
+              <a:srgbClr val="57B8E8"/>
             </a:solidFill>
           </a:ln>
         </p:spPr>
@@ -3529,14 +3620,14 @@
       </p:sp>
       <p:sp>
         <p:nvSpPr>
-          <p:cNvPr id="10" name="TextBox 9"/>
+          <p:cNvPr id="12" name="TextBox 11"/>
           <p:cNvSpPr txBox="1"/>
           <p:nvPr/>
         </p:nvSpPr>
         <p:spPr>
           <a:xfrm>
-            <a:off x="8366759" y="2926080"/>
-            <a:ext cx="2834640" cy="1554480"/>
+            <a:off x="8485632" y="3108960"/>
+            <a:ext cx="2834640" cy="292608"/>
           </a:xfrm>
           <a:prstGeom prst="rect">
             <a:avLst/>
@@ -3544,35 +3635,102 @@
           <a:noFill/>
         </p:spPr>
         <p:txBody>
-          <a:bodyPr wrap="none">
+          <a:bodyPr wrap="square" anchor="t">
             <a:spAutoFit/>
           </a:bodyPr>
           <a:lstStyle/>
           <a:p>
-            <a:pPr>
-              <a:defRPr sz="2100" b="1">
-                <a:solidFill>
-                  <a:srgbClr val="54CFFF"/>
-                </a:solidFill>
+            <a:pPr algn="l">
+              <a:lnSpc>
+                <a:spcPct val="120000"/>
+              </a:lnSpc>
+              <a:defRPr sz="1900" b="1">
+                <a:solidFill>
+                  <a:srgbClr val="57D6FF"/>
+                </a:solidFill>
+                <a:latin typeface="Aptos"/>
               </a:defRPr>
             </a:pPr>
             <a:r>
-              <a:t>Trend</a:t>
-            </a:r>
-          </a:p>
-          <a:p>
-            <a:pPr>
-              <a:spcBef>
-                <a:spcPts val="800"/>
-              </a:spcBef>
-              <a:defRPr sz="1500">
+              <a:t>Bewertung</a:t>
+            </a:r>
+          </a:p>
+        </p:txBody>
+      </p:sp>
+      <p:sp>
+        <p:nvSpPr>
+          <p:cNvPr id="13" name="TextBox 12"/>
+          <p:cNvSpPr txBox="1"/>
+          <p:nvPr/>
+        </p:nvSpPr>
+        <p:spPr>
+          <a:xfrm>
+            <a:off x="8485632" y="3493008"/>
+            <a:ext cx="2880360" cy="1005840"/>
+          </a:xfrm>
+          <a:prstGeom prst="rect">
+            <a:avLst/>
+          </a:prstGeom>
+          <a:noFill/>
+        </p:spPr>
+        <p:txBody>
+          <a:bodyPr wrap="square" anchor="t">
+            <a:spAutoFit/>
+          </a:bodyPr>
+          <a:lstStyle/>
+          <a:p>
+            <a:pPr algn="l">
+              <a:lnSpc>
+                <a:spcPct val="120000"/>
+              </a:lnSpc>
+              <a:defRPr sz="1400" b="0">
                 <a:solidFill>
                   <a:srgbClr val="E2ECF4"/>
                 </a:solidFill>
+                <a:latin typeface="Aptos"/>
               </a:defRPr>
             </a:pPr>
             <a:r>
-              <a:t>Wegen Quecksilber und Effizienz wird zunehmend auf LED umgestellt.</a:t>
+              <a:t>Wegen Quecksilber, Schaltverhalten und LED-Fortschritt sinkt ihre Bedeutung.</a:t>
+            </a:r>
+          </a:p>
+        </p:txBody>
+      </p:sp>
+      <p:sp>
+        <p:nvSpPr>
+          <p:cNvPr id="14" name="TextBox 13"/>
+          <p:cNvSpPr txBox="1"/>
+          <p:nvPr/>
+        </p:nvSpPr>
+        <p:spPr>
+          <a:xfrm>
+            <a:off x="3337560" y="5669280"/>
+            <a:ext cx="5486400" cy="320040"/>
+          </a:xfrm>
+          <a:prstGeom prst="rect">
+            <a:avLst/>
+          </a:prstGeom>
+          <a:noFill/>
+        </p:spPr>
+        <p:txBody>
+          <a:bodyPr wrap="square" anchor="t">
+            <a:spAutoFit/>
+          </a:bodyPr>
+          <a:lstStyle/>
+          <a:p>
+            <a:pPr algn="ctr">
+              <a:lnSpc>
+                <a:spcPct val="120000"/>
+              </a:lnSpc>
+              <a:defRPr sz="1700" b="1">
+                <a:solidFill>
+                  <a:srgbClr val="B8D0E2"/>
+                </a:solidFill>
+                <a:latin typeface="Aptos"/>
+              </a:defRPr>
+            </a:pPr>
+            <a:r>
+              <a:t>Danke für eure Aufmerksamkeit</a:t>
             </a:r>
           </a:p>
         </p:txBody>
@@ -3591,7 +3749,7 @@
     <p:bg>
       <p:bgPr>
         <a:solidFill>
-          <a:srgbClr val="F6F9FC"/>
+          <a:srgbClr val="F6F8FB"/>
         </a:solidFill>
         <a:effectLst/>
       </p:bgPr>
@@ -3611,8 +3769,8 @@
         </p:nvSpPr>
         <p:spPr>
           <a:xfrm>
-            <a:off x="594360" y="320040"/>
-            <a:ext cx="8046720" cy="822960"/>
+            <a:off x="640080" y="411480"/>
+            <a:ext cx="9601200" cy="548640"/>
           </a:xfrm>
           <a:prstGeom prst="rect">
             <a:avLst/>
@@ -3620,19 +3778,24 @@
           <a:noFill/>
         </p:spPr>
         <p:txBody>
-          <a:bodyPr wrap="none">
+          <a:bodyPr wrap="square" anchor="t">
             <a:spAutoFit/>
           </a:bodyPr>
           <a:lstStyle/>
           <a:p>
-            <a:r>
-              <a:rPr b="1" sz="2500">
+            <a:pPr algn="l">
+              <a:lnSpc>
+                <a:spcPct val="120000"/>
+              </a:lnSpc>
+              <a:defRPr sz="2500" b="1">
                 <a:solidFill>
                   <a:srgbClr val="142C48"/>
                 </a:solidFill>
                 <a:latin typeface="Aptos Display"/>
-              </a:rPr>
-              <a:t>Was macht Leuchtstofflampen besonders?</a:t>
+              </a:defRPr>
+            </a:pPr>
+            <a:r>
+              <a:t>Warum ist die Leuchtstofflampe im Berufsalltag wichtig?</a:t>
             </a:r>
           </a:p>
         </p:txBody>
@@ -3645,8 +3808,8 @@
         </p:nvSpPr>
         <p:spPr>
           <a:xfrm>
-            <a:off x="621792" y="914400"/>
-            <a:ext cx="7315200" cy="411480"/>
+            <a:off x="658368" y="868680"/>
+            <a:ext cx="9875520" cy="320040"/>
           </a:xfrm>
           <a:prstGeom prst="rect">
             <a:avLst/>
@@ -3654,18 +3817,24 @@
           <a:noFill/>
         </p:spPr>
         <p:txBody>
-          <a:bodyPr wrap="none">
+          <a:bodyPr wrap="square" anchor="t">
             <a:spAutoFit/>
           </a:bodyPr>
           <a:lstStyle/>
           <a:p>
-            <a:r>
-              <a:rPr sz="1200">
-                <a:solidFill>
-                  <a:srgbClr val="646F7E"/>
-                </a:solidFill>
-              </a:rPr>
-              <a:t>Die Technologie prägte jahrzehntelang Beleuchtung in Arbeits- und Lernräumen.</a:t>
+            <a:pPr algn="l">
+              <a:lnSpc>
+                <a:spcPct val="120000"/>
+              </a:lnSpc>
+              <a:defRPr sz="1200" b="0">
+                <a:solidFill>
+                  <a:srgbClr val="63707C"/>
+                </a:solidFill>
+                <a:latin typeface="Aptos"/>
+              </a:defRPr>
+            </a:pPr>
+            <a:r>
+              <a:t>Einordnung für Elektrotechnik, Beleuchtungstechnik und Gebäudepraxis</a:t>
             </a:r>
           </a:p>
         </p:txBody>
@@ -3678,8 +3847,8 @@
         </p:nvSpPr>
         <p:spPr>
           <a:xfrm>
-            <a:off x="731520" y="1645920"/>
-            <a:ext cx="3291840" cy="3017520"/>
+            <a:off x="731520" y="1554480"/>
+            <a:ext cx="3474720" cy="1874519"/>
           </a:xfrm>
           <a:prstGeom prst="roundRect">
             <a:avLst/>
@@ -3689,7 +3858,7 @@
           </a:solidFill>
           <a:ln>
             <a:solidFill>
-              <a:srgbClr val="DCE4EC"/>
+              <a:srgbClr val="E0E7ED"/>
             </a:solidFill>
           </a:ln>
         </p:spPr>
@@ -3723,8 +3892,8 @@
         </p:nvSpPr>
         <p:spPr>
           <a:xfrm>
-            <a:off x="960120" y="1874519"/>
-            <a:ext cx="2743200" cy="2468880"/>
+            <a:off x="932688" y="1719072"/>
+            <a:ext cx="3154680" cy="384048"/>
           </a:xfrm>
           <a:prstGeom prst="rect">
             <a:avLst/>
@@ -3732,49 +3901,77 @@
           <a:noFill/>
         </p:spPr>
         <p:txBody>
-          <a:bodyPr wrap="none">
+          <a:bodyPr wrap="square" anchor="t">
             <a:spAutoFit/>
           </a:bodyPr>
           <a:lstStyle/>
           <a:p>
-            <a:pPr>
-              <a:defRPr b="1" sz="2200">
+            <a:pPr algn="l">
+              <a:lnSpc>
+                <a:spcPct val="120000"/>
+              </a:lnSpc>
+              <a:defRPr sz="1800" b="1">
                 <a:solidFill>
                   <a:srgbClr val="142C48"/>
                 </a:solidFill>
+                <a:latin typeface="Aptos"/>
               </a:defRPr>
             </a:pPr>
             <a:r>
-              <a:t>Prinzip</a:t>
-            </a:r>
-          </a:p>
-          <a:p>
-            <a:pPr>
-              <a:spcBef>
-                <a:spcPts val="1200"/>
-              </a:spcBef>
-              <a:defRPr sz="1500">
-                <a:solidFill>
-                  <a:srgbClr val="4C5967"/>
-                </a:solidFill>
+              <a:t>Technischer Kern</a:t>
+            </a:r>
+          </a:p>
+        </p:txBody>
+      </p:sp>
+      <p:sp>
+        <p:nvSpPr>
+          <p:cNvPr id="6" name="TextBox 5"/>
+          <p:cNvSpPr txBox="1"/>
+          <p:nvPr/>
+        </p:nvSpPr>
+        <p:spPr>
+          <a:xfrm>
+            <a:off x="932688" y="2084832"/>
+            <a:ext cx="3154680" cy="1188719"/>
+          </a:xfrm>
+          <a:prstGeom prst="rect">
+            <a:avLst/>
+          </a:prstGeom>
+          <a:noFill/>
+        </p:spPr>
+        <p:txBody>
+          <a:bodyPr wrap="square" anchor="t">
+            <a:spAutoFit/>
+          </a:bodyPr>
+          <a:lstStyle/>
+          <a:p>
+            <a:pPr algn="l">
+              <a:lnSpc>
+                <a:spcPct val="120000"/>
+              </a:lnSpc>
+              <a:defRPr sz="1300" b="0">
+                <a:solidFill>
+                  <a:srgbClr val="485461"/>
+                </a:solidFill>
+                <a:latin typeface="Aptos"/>
               </a:defRPr>
             </a:pPr>
             <a:r>
-              <a:t>Gasentladung erzeugt UV-Strahlung; die Leuchtstoffschicht wandelt diese in sichtbares Licht um.</a:t>
-            </a:r>
-          </a:p>
-        </p:txBody>
-      </p:sp>
-      <p:sp>
-        <p:nvSpPr>
-          <p:cNvPr id="6" name="Rounded Rectangle 5"/>
+              <a:t>Sie gehört zu den Gasentladungslampen. Das sichtbare Licht entsteht erst über die Leuchtstoffschicht im Inneren.</a:t>
+            </a:r>
+          </a:p>
+        </p:txBody>
+      </p:sp>
+      <p:sp>
+        <p:nvSpPr>
+          <p:cNvPr id="7" name="Rounded Rectangle 6"/>
           <p:cNvSpPr/>
           <p:nvPr/>
         </p:nvSpPr>
         <p:spPr>
           <a:xfrm>
-            <a:off x="4480559" y="1645920"/>
-            <a:ext cx="3291840" cy="3017520"/>
+            <a:off x="4361688" y="1554480"/>
+            <a:ext cx="3474720" cy="1874519"/>
           </a:xfrm>
           <a:prstGeom prst="roundRect">
             <a:avLst/>
@@ -3784,7 +3981,7 @@
           </a:solidFill>
           <a:ln>
             <a:solidFill>
-              <a:srgbClr val="DCE4EC"/>
+              <a:srgbClr val="E0E7ED"/>
             </a:solidFill>
           </a:ln>
         </p:spPr>
@@ -3812,14 +4009,14 @@
       </p:sp>
       <p:sp>
         <p:nvSpPr>
-          <p:cNvPr id="7" name="TextBox 6"/>
+          <p:cNvPr id="8" name="TextBox 7"/>
           <p:cNvSpPr txBox="1"/>
           <p:nvPr/>
         </p:nvSpPr>
         <p:spPr>
           <a:xfrm>
-            <a:off x="4709159" y="1874519"/>
-            <a:ext cx="2743200" cy="2468880"/>
+            <a:off x="4562856" y="1719072"/>
+            <a:ext cx="3154680" cy="384048"/>
           </a:xfrm>
           <a:prstGeom prst="rect">
             <a:avLst/>
@@ -3827,49 +4024,77 @@
           <a:noFill/>
         </p:spPr>
         <p:txBody>
-          <a:bodyPr wrap="none">
+          <a:bodyPr wrap="square" anchor="t">
             <a:spAutoFit/>
           </a:bodyPr>
           <a:lstStyle/>
           <a:p>
-            <a:pPr>
-              <a:defRPr b="1" sz="2200">
+            <a:pPr algn="l">
+              <a:lnSpc>
+                <a:spcPct val="120000"/>
+              </a:lnSpc>
+              <a:defRPr sz="1800" b="1">
                 <a:solidFill>
                   <a:srgbClr val="142C48"/>
                 </a:solidFill>
+                <a:latin typeface="Aptos"/>
               </a:defRPr>
             </a:pPr>
             <a:r>
-              <a:t>Stärken</a:t>
-            </a:r>
-          </a:p>
-          <a:p>
-            <a:pPr>
-              <a:spcBef>
-                <a:spcPts val="1200"/>
-              </a:spcBef>
-              <a:defRPr sz="1500">
-                <a:solidFill>
-                  <a:srgbClr val="4C5967"/>
-                </a:solidFill>
+              <a:t>Praxisbezug</a:t>
+            </a:r>
+          </a:p>
+        </p:txBody>
+      </p:sp>
+      <p:sp>
+        <p:nvSpPr>
+          <p:cNvPr id="9" name="TextBox 8"/>
+          <p:cNvSpPr txBox="1"/>
+          <p:nvPr/>
+        </p:nvSpPr>
+        <p:spPr>
+          <a:xfrm>
+            <a:off x="4562856" y="2084832"/>
+            <a:ext cx="3154680" cy="1188719"/>
+          </a:xfrm>
+          <a:prstGeom prst="rect">
+            <a:avLst/>
+          </a:prstGeom>
+          <a:noFill/>
+        </p:spPr>
+        <p:txBody>
+          <a:bodyPr wrap="square" anchor="t">
+            <a:spAutoFit/>
+          </a:bodyPr>
+          <a:lstStyle/>
+          <a:p>
+            <a:pPr algn="l">
+              <a:lnSpc>
+                <a:spcPct val="120000"/>
+              </a:lnSpc>
+              <a:defRPr sz="1300" b="0">
+                <a:solidFill>
+                  <a:srgbClr val="485461"/>
+                </a:solidFill>
+                <a:latin typeface="Aptos"/>
               </a:defRPr>
             </a:pPr>
             <a:r>
-              <a:t>Gute Lichtausbeute, gleichmäßige Ausleuchtung und viele Lichtfarben.</a:t>
-            </a:r>
-          </a:p>
-        </p:txBody>
-      </p:sp>
-      <p:sp>
-        <p:nvSpPr>
-          <p:cNvPr id="8" name="Rounded Rectangle 7"/>
+              <a:t>In Schulen, Büros und Werkhallen war diese Lampenart lange Standard, weil sie große Räume wirtschaftlich ausleuchtet.</a:t>
+            </a:r>
+          </a:p>
+        </p:txBody>
+      </p:sp>
+      <p:sp>
+        <p:nvSpPr>
+          <p:cNvPr id="10" name="Rounded Rectangle 9"/>
           <p:cNvSpPr/>
           <p:nvPr/>
         </p:nvSpPr>
         <p:spPr>
           <a:xfrm>
-            <a:off x="8229600" y="1645920"/>
-            <a:ext cx="3291840" cy="3017520"/>
+            <a:off x="7991856" y="1554480"/>
+            <a:ext cx="3474720" cy="1874519"/>
           </a:xfrm>
           <a:prstGeom prst="roundRect">
             <a:avLst/>
@@ -3879,7 +4104,7 @@
           </a:solidFill>
           <a:ln>
             <a:solidFill>
-              <a:srgbClr val="DCE4EC"/>
+              <a:srgbClr val="E0E7ED"/>
             </a:solidFill>
           </a:ln>
         </p:spPr>
@@ -3907,14 +4132,14 @@
       </p:sp>
       <p:sp>
         <p:nvSpPr>
-          <p:cNvPr id="9" name="TextBox 8"/>
+          <p:cNvPr id="11" name="TextBox 10"/>
           <p:cNvSpPr txBox="1"/>
           <p:nvPr/>
         </p:nvSpPr>
         <p:spPr>
           <a:xfrm>
-            <a:off x="8458200" y="1874519"/>
-            <a:ext cx="2743200" cy="2468880"/>
+            <a:off x="8193024" y="1719072"/>
+            <a:ext cx="3154680" cy="384048"/>
           </a:xfrm>
           <a:prstGeom prst="rect">
             <a:avLst/>
@@ -3922,35 +4147,231 @@
           <a:noFill/>
         </p:spPr>
         <p:txBody>
-          <a:bodyPr wrap="none">
+          <a:bodyPr wrap="square" anchor="t">
             <a:spAutoFit/>
           </a:bodyPr>
           <a:lstStyle/>
           <a:p>
+            <a:pPr algn="l">
+              <a:lnSpc>
+                <a:spcPct val="120000"/>
+              </a:lnSpc>
+              <a:defRPr sz="1800" b="1">
+                <a:solidFill>
+                  <a:srgbClr val="142C48"/>
+                </a:solidFill>
+                <a:latin typeface="Aptos"/>
+              </a:defRPr>
+            </a:pPr>
+            <a:r>
+              <a:t>Heute relevant, weil …</a:t>
+            </a:r>
+          </a:p>
+        </p:txBody>
+      </p:sp>
+      <p:sp>
+        <p:nvSpPr>
+          <p:cNvPr id="12" name="TextBox 11"/>
+          <p:cNvSpPr txBox="1"/>
+          <p:nvPr/>
+        </p:nvSpPr>
+        <p:spPr>
+          <a:xfrm>
+            <a:off x="8193024" y="2084832"/>
+            <a:ext cx="3154680" cy="1188719"/>
+          </a:xfrm>
+          <a:prstGeom prst="rect">
+            <a:avLst/>
+          </a:prstGeom>
+          <a:noFill/>
+        </p:spPr>
+        <p:txBody>
+          <a:bodyPr wrap="square" anchor="t">
+            <a:spAutoFit/>
+          </a:bodyPr>
+          <a:lstStyle/>
+          <a:p>
+            <a:pPr algn="l">
+              <a:lnSpc>
+                <a:spcPct val="120000"/>
+              </a:lnSpc>
+              <a:defRPr sz="1300" b="0">
+                <a:solidFill>
+                  <a:srgbClr val="485461"/>
+                </a:solidFill>
+                <a:latin typeface="Aptos"/>
+              </a:defRPr>
+            </a:pPr>
+            <a:r>
+              <a:t>… Bestandsanlagen weiterhin existieren und der Vergleich mit moderner LED-Technik in der Berufsschule wichtig ist.</a:t>
+            </a:r>
+          </a:p>
+        </p:txBody>
+      </p:sp>
+      <p:sp>
+        <p:nvSpPr>
+          <p:cNvPr id="13" name="TextBox 12"/>
+          <p:cNvSpPr txBox="1"/>
+          <p:nvPr/>
+        </p:nvSpPr>
+        <p:spPr>
+          <a:xfrm>
+            <a:off x="868680" y="3886200"/>
+            <a:ext cx="5212080" cy="1737360"/>
+          </a:xfrm>
+          <a:prstGeom prst="rect">
+            <a:avLst/>
+          </a:prstGeom>
+          <a:noFill/>
+        </p:spPr>
+        <p:txBody>
+          <a:bodyPr wrap="square" anchor="t">
+            <a:spAutoFit/>
+          </a:bodyPr>
+          <a:lstStyle/>
+          <a:p>
+            <a:pPr algn="l">
+              <a:lnSpc>
+                <a:spcPct val="120000"/>
+              </a:lnSpc>
+              <a:defRPr sz="1700" b="0">
+                <a:solidFill>
+                  <a:srgbClr val="364351"/>
+                </a:solidFill>
+                <a:latin typeface="Aptos"/>
+              </a:defRPr>
+            </a:pPr>
+            <a:r>
+              <a:t>Diese Präsentation behandelt genau die Punkte aus dem Arbeitsauftrag:</a:t>
+            </a:r>
+          </a:p>
+          <a:p>
             <a:pPr>
-              <a:defRPr b="1" sz="2200">
-                <a:solidFill>
-                  <a:srgbClr val="142C48"/>
-                </a:solidFill>
+              <a:lnSpc>
+                <a:spcPct val="120000"/>
+              </a:lnSpc>
+              <a:defRPr sz="1700" b="0">
+                <a:solidFill>
+                  <a:srgbClr val="364351"/>
+                </a:solidFill>
+                <a:latin typeface="Aptos"/>
               </a:defRPr>
             </a:pPr>
-            <a:r>
-              <a:t>Grenzen</a:t>
-            </a:r>
           </a:p>
           <a:p>
             <a:pPr>
-              <a:spcBef>
-                <a:spcPts val="1200"/>
-              </a:spcBef>
-              <a:defRPr sz="1500">
-                <a:solidFill>
-                  <a:srgbClr val="4C5967"/>
-                </a:solidFill>
+              <a:lnSpc>
+                <a:spcPct val="120000"/>
+              </a:lnSpc>
+              <a:defRPr sz="1700" b="0">
+                <a:solidFill>
+                  <a:srgbClr val="364351"/>
+                </a:solidFill>
+                <a:latin typeface="Aptos"/>
               </a:defRPr>
             </a:pPr>
             <a:r>
-              <a:t>Quecksilber, Anlaufzeit und Schaltfestigkeit sind die größten Nachteile.</a:t>
+              <a:t>Aufbau, Funktionsweise, Betriebsverhalten, Bauformen, Lichtfarben, Besonderheiten und typische Einsatzbereiche.</a:t>
+            </a:r>
+          </a:p>
+        </p:txBody>
+      </p:sp>
+      <p:sp>
+        <p:nvSpPr>
+          <p:cNvPr id="14" name="Rounded Rectangle 13"/>
+          <p:cNvSpPr/>
+          <p:nvPr/>
+        </p:nvSpPr>
+        <p:spPr>
+          <a:xfrm>
+            <a:off x="6629400" y="3822191"/>
+            <a:ext cx="4846320" cy="1783080"/>
+          </a:xfrm>
+          <a:prstGeom prst="roundRect">
+            <a:avLst/>
+          </a:prstGeom>
+          <a:solidFill>
+            <a:srgbClr val="185C97"/>
+          </a:solidFill>
+          <a:ln>
+            <a:solidFill>
+              <a:srgbClr val="185C97"/>
+            </a:solidFill>
+          </a:ln>
+        </p:spPr>
+        <p:style>
+          <a:lnRef idx="1">
+            <a:schemeClr val="accent1"/>
+          </a:lnRef>
+          <a:fillRef idx="3">
+            <a:schemeClr val="accent1"/>
+          </a:fillRef>
+          <a:effectRef idx="2">
+            <a:schemeClr val="accent1"/>
+          </a:effectRef>
+          <a:fontRef idx="minor">
+            <a:schemeClr val="lt1"/>
+          </a:fontRef>
+        </p:style>
+        <p:txBody>
+          <a:bodyPr rtlCol="0" anchor="ctr"/>
+          <a:lstStyle/>
+          <a:p>
+            <a:pPr algn="ctr"/>
+          </a:p>
+        </p:txBody>
+      </p:sp>
+      <p:sp>
+        <p:nvSpPr>
+          <p:cNvPr id="15" name="TextBox 14"/>
+          <p:cNvSpPr txBox="1"/>
+          <p:nvPr/>
+        </p:nvSpPr>
+        <p:spPr>
+          <a:xfrm>
+            <a:off x="6903720" y="4114800"/>
+            <a:ext cx="4297680" cy="1234440"/>
+          </a:xfrm>
+          <a:prstGeom prst="rect">
+            <a:avLst/>
+          </a:prstGeom>
+          <a:noFill/>
+        </p:spPr>
+        <p:txBody>
+          <a:bodyPr wrap="square" anchor="t">
+            <a:spAutoFit/>
+          </a:bodyPr>
+          <a:lstStyle/>
+          <a:p>
+            <a:pPr algn="l">
+              <a:lnSpc>
+                <a:spcPct val="120000"/>
+              </a:lnSpc>
+              <a:defRPr sz="1800" b="0">
+                <a:solidFill>
+                  <a:srgbClr val="FFFFFF"/>
+                </a:solidFill>
+                <a:latin typeface="Aptos"/>
+              </a:defRPr>
+            </a:pPr>
+            <a:r>
+              <a:t>Merksatz:</a:t>
+            </a:r>
+          </a:p>
+          <a:p>
+            <a:pPr>
+              <a:lnSpc>
+                <a:spcPct val="120000"/>
+              </a:lnSpc>
+              <a:defRPr sz="1800" b="0">
+                <a:solidFill>
+                  <a:srgbClr val="FFFFFF"/>
+                </a:solidFill>
+                <a:latin typeface="Aptos"/>
+              </a:defRPr>
+            </a:pPr>
+            <a:r>
+              <a:t>Leuchtstofflampen sind effizienter als Glühlampen, aber in vielen Bereichen bereits von LEDs verdrängt.</a:t>
             </a:r>
           </a:p>
         </p:txBody>
@@ -3969,7 +4390,7 @@
     <p:bg>
       <p:bgPr>
         <a:solidFill>
-          <a:srgbClr val="FAFCFE"/>
+          <a:srgbClr val="F9FBFD"/>
         </a:solidFill>
         <a:effectLst/>
       </p:bgPr>
@@ -3989,8 +4410,8 @@
         </p:nvSpPr>
         <p:spPr>
           <a:xfrm>
-            <a:off x="594360" y="320040"/>
-            <a:ext cx="8046720" cy="822960"/>
+            <a:off x="640080" y="411480"/>
+            <a:ext cx="9601200" cy="548640"/>
           </a:xfrm>
           <a:prstGeom prst="rect">
             <a:avLst/>
@@ -3998,18 +4419,23 @@
           <a:noFill/>
         </p:spPr>
         <p:txBody>
-          <a:bodyPr wrap="none">
+          <a:bodyPr wrap="square" anchor="t">
             <a:spAutoFit/>
           </a:bodyPr>
           <a:lstStyle/>
           <a:p>
-            <a:r>
-              <a:rPr b="1" sz="2500">
+            <a:pPr algn="l">
+              <a:lnSpc>
+                <a:spcPct val="120000"/>
+              </a:lnSpc>
+              <a:defRPr sz="2500" b="1">
                 <a:solidFill>
                   <a:srgbClr val="142C48"/>
                 </a:solidFill>
                 <a:latin typeface="Aptos Display"/>
-              </a:rPr>
+              </a:defRPr>
+            </a:pPr>
+            <a:r>
               <a:t>Aufbau einer Leuchtstofflampe</a:t>
             </a:r>
           </a:p>
@@ -4023,8 +4449,8 @@
         </p:nvSpPr>
         <p:spPr>
           <a:xfrm>
-            <a:off x="621792" y="914400"/>
-            <a:ext cx="7315200" cy="411480"/>
+            <a:off x="658368" y="868680"/>
+            <a:ext cx="9875520" cy="320040"/>
           </a:xfrm>
           <a:prstGeom prst="rect">
             <a:avLst/>
@@ -4032,25 +4458,31 @@
           <a:noFill/>
         </p:spPr>
         <p:txBody>
-          <a:bodyPr wrap="none">
+          <a:bodyPr wrap="square" anchor="t">
             <a:spAutoFit/>
           </a:bodyPr>
           <a:lstStyle/>
           <a:p>
-            <a:r>
-              <a:rPr sz="1200">
-                <a:solidFill>
-                  <a:srgbClr val="646F7E"/>
-                </a:solidFill>
-              </a:rPr>
-              <a:t>Wichtige Bauteile und ihre Aufgabe im Stromkreis</a:t>
+            <a:pPr algn="l">
+              <a:lnSpc>
+                <a:spcPct val="120000"/>
+              </a:lnSpc>
+              <a:defRPr sz="1200" b="0">
+                <a:solidFill>
+                  <a:srgbClr val="63707C"/>
+                </a:solidFill>
+                <a:latin typeface="Aptos"/>
+              </a:defRPr>
+            </a:pPr>
+            <a:r>
+              <a:t>Die wichtigsten Bauteile in einer übersichtlichen technischen Darstellung</a:t>
             </a:r>
           </a:p>
         </p:txBody>
       </p:sp>
       <p:pic>
         <p:nvPicPr>
-          <p:cNvPr id="4" name="Picture 3" descr="aufbau.png"/>
+          <p:cNvPr id="4" name="Picture 3" descr="tech_cutaway.png"/>
           <p:cNvPicPr>
             <a:picLocks noChangeAspect="1"/>
           </p:cNvPicPr>
@@ -4064,8 +4496,8 @@
         </p:blipFill>
         <p:spPr>
           <a:xfrm>
-            <a:off x="411480" y="1234440"/>
-            <a:ext cx="7315200" cy="4389120"/>
+            <a:off x="384048" y="1298448"/>
+            <a:ext cx="7406640" cy="4892040"/>
           </a:xfrm>
           <a:prstGeom prst="rect">
             <a:avLst/>
@@ -4080,8 +4512,8 @@
         </p:nvSpPr>
         <p:spPr>
           <a:xfrm>
-            <a:off x="8046720" y="1508760"/>
-            <a:ext cx="3474720" cy="4023360"/>
+            <a:off x="8138160" y="1600200"/>
+            <a:ext cx="3383280" cy="2286000"/>
           </a:xfrm>
           <a:prstGeom prst="rect">
             <a:avLst/>
@@ -4089,83 +4521,103 @@
           <a:noFill/>
         </p:spPr>
         <p:txBody>
-          <a:bodyPr wrap="none">
+          <a:bodyPr wrap="square">
             <a:spAutoFit/>
           </a:bodyPr>
           <a:lstStyle/>
           <a:p>
             <a:pPr>
+              <a:lnSpc>
+                <a:spcPct val="115000"/>
+              </a:lnSpc>
               <a:spcAft>
-                <a:spcPts val="700"/>
+                <a:spcPts val="400"/>
               </a:spcAft>
               <a:defRPr sz="1500">
                 <a:solidFill>
-                  <a:srgbClr val="3A4653"/>
-                </a:solidFill>
+                  <a:srgbClr val="3C4854"/>
+                </a:solidFill>
+                <a:latin typeface="Aptos"/>
               </a:defRPr>
             </a:pPr>
             <a:r>
-              <a:t>Glasrohr schützt die Bauteile und führt die Entladung.</a:t>
+              <a:t>• Glasrohr schützt die Komponenten und führt die Entladung.</a:t>
             </a:r>
           </a:p>
           <a:p>
             <a:pPr>
+              <a:lnSpc>
+                <a:spcPct val="115000"/>
+              </a:lnSpc>
               <a:spcAft>
-                <a:spcPts val="700"/>
+                <a:spcPts val="400"/>
               </a:spcAft>
               <a:defRPr sz="1500">
                 <a:solidFill>
-                  <a:srgbClr val="3A4653"/>
-                </a:solidFill>
+                  <a:srgbClr val="3C4854"/>
+                </a:solidFill>
+                <a:latin typeface="Aptos"/>
               </a:defRPr>
             </a:pPr>
             <a:r>
-              <a:t>Elektroden zünden die Entladung beim Einschalten.</a:t>
+              <a:t>• Elektroden an den Enden zünden die Lampe beim Start.</a:t>
             </a:r>
           </a:p>
           <a:p>
             <a:pPr>
+              <a:lnSpc>
+                <a:spcPct val="115000"/>
+              </a:lnSpc>
               <a:spcAft>
-                <a:spcPts val="700"/>
+                <a:spcPts val="400"/>
               </a:spcAft>
               <a:defRPr sz="1500">
                 <a:solidFill>
-                  <a:srgbClr val="3A4653"/>
-                </a:solidFill>
+                  <a:srgbClr val="3C4854"/>
+                </a:solidFill>
+                <a:latin typeface="Aptos"/>
               </a:defRPr>
             </a:pPr>
             <a:r>
-              <a:t>Quecksilberdampf und Edelgas erzeugen UV-Strahlung.</a:t>
+              <a:t>• Edelgas und Quecksilberdampf erzeugen UV-Strahlung.</a:t>
             </a:r>
           </a:p>
           <a:p>
             <a:pPr>
+              <a:lnSpc>
+                <a:spcPct val="115000"/>
+              </a:lnSpc>
               <a:spcAft>
-                <a:spcPts val="700"/>
+                <a:spcPts val="400"/>
               </a:spcAft>
               <a:defRPr sz="1500">
                 <a:solidFill>
-                  <a:srgbClr val="3A4653"/>
-                </a:solidFill>
+                  <a:srgbClr val="3C4854"/>
+                </a:solidFill>
+                <a:latin typeface="Aptos"/>
               </a:defRPr>
             </a:pPr>
             <a:r>
-              <a:t>Leuchtstoffschicht wandelt UV in sichtbares Licht um.</a:t>
+              <a:t>• Die Leuchtstoffschicht wandelt UV in sichtbares Licht um.</a:t>
             </a:r>
           </a:p>
           <a:p>
             <a:pPr>
+              <a:lnSpc>
+                <a:spcPct val="115000"/>
+              </a:lnSpc>
               <a:spcAft>
-                <a:spcPts val="700"/>
+                <a:spcPts val="400"/>
               </a:spcAft>
               <a:defRPr sz="1500">
                 <a:solidFill>
-                  <a:srgbClr val="3A4653"/>
-                </a:solidFill>
+                  <a:srgbClr val="3C4854"/>
+                </a:solidFill>
+                <a:latin typeface="Aptos"/>
               </a:defRPr>
             </a:pPr>
             <a:r>
-              <a:t>Vorschaltgerät begrenzt den Strom und stabilisiert den Betrieb.</a:t>
+              <a:t>• Ein Vorschaltgerät begrenzt den Strom im Betrieb.</a:t>
             </a:r>
           </a:p>
         </p:txBody>
@@ -4184,7 +4636,7 @@
     <p:bg>
       <p:bgPr>
         <a:solidFill>
-          <a:srgbClr val="EDF4F9"/>
+          <a:srgbClr val="F4F8FB"/>
         </a:solidFill>
         <a:effectLst/>
       </p:bgPr>
@@ -4204,8 +4656,8 @@
         </p:nvSpPr>
         <p:spPr>
           <a:xfrm>
-            <a:off x="594360" y="320040"/>
-            <a:ext cx="8046720" cy="822960"/>
+            <a:off x="640080" y="411480"/>
+            <a:ext cx="9601200" cy="548640"/>
           </a:xfrm>
           <a:prstGeom prst="rect">
             <a:avLst/>
@@ -4213,19 +4665,24 @@
           <a:noFill/>
         </p:spPr>
         <p:txBody>
-          <a:bodyPr wrap="none">
+          <a:bodyPr wrap="square" anchor="t">
             <a:spAutoFit/>
           </a:bodyPr>
           <a:lstStyle/>
           <a:p>
-            <a:r>
-              <a:rPr b="1" sz="2500">
+            <a:pPr algn="l">
+              <a:lnSpc>
+                <a:spcPct val="120000"/>
+              </a:lnSpc>
+              <a:defRPr sz="2500" b="1">
                 <a:solidFill>
                   <a:srgbClr val="142C48"/>
                 </a:solidFill>
                 <a:latin typeface="Aptos Display"/>
-              </a:rPr>
-              <a:t>Funktionsweise</a:t>
+              </a:defRPr>
+            </a:pPr>
+            <a:r>
+              <a:t>Funktionsweise Schritt für Schritt</a:t>
             </a:r>
           </a:p>
         </p:txBody>
@@ -4238,8 +4695,8 @@
         </p:nvSpPr>
         <p:spPr>
           <a:xfrm>
-            <a:off x="621792" y="914400"/>
-            <a:ext cx="7315200" cy="411480"/>
+            <a:off x="658368" y="868680"/>
+            <a:ext cx="9875520" cy="320040"/>
           </a:xfrm>
           <a:prstGeom prst="rect">
             <a:avLst/>
@@ -4247,25 +4704,31 @@
           <a:noFill/>
         </p:spPr>
         <p:txBody>
-          <a:bodyPr wrap="none">
+          <a:bodyPr wrap="square" anchor="t">
             <a:spAutoFit/>
           </a:bodyPr>
           <a:lstStyle/>
           <a:p>
-            <a:r>
-              <a:rPr sz="1200">
-                <a:solidFill>
-                  <a:srgbClr val="646F7E"/>
-                </a:solidFill>
-              </a:rPr>
-              <a:t>Vom Einschalten bis zum sichtbaren Licht</a:t>
+            <a:pPr algn="l">
+              <a:lnSpc>
+                <a:spcPct val="120000"/>
+              </a:lnSpc>
+              <a:defRPr sz="1200" b="0">
+                <a:solidFill>
+                  <a:srgbClr val="63707C"/>
+                </a:solidFill>
+                <a:latin typeface="Aptos"/>
+              </a:defRPr>
+            </a:pPr>
+            <a:r>
+              <a:t>Vom Einschalten bis zur gleichmäßigen Lichtabgabe</a:t>
             </a:r>
           </a:p>
         </p:txBody>
       </p:sp>
       <p:pic>
         <p:nvPicPr>
-          <p:cNvPr id="4" name="Picture 3" descr="funktion.png"/>
+          <p:cNvPr id="4" name="Picture 3" descr="function_flow.png"/>
           <p:cNvPicPr>
             <a:picLocks noChangeAspect="1"/>
           </p:cNvPicPr>
@@ -4279,8 +4742,8 @@
         </p:blipFill>
         <p:spPr>
           <a:xfrm>
-            <a:off x="411480" y="1325880"/>
-            <a:ext cx="11338560" cy="4846320"/>
+            <a:off x="320040" y="1353312"/>
+            <a:ext cx="11567160" cy="4846320"/>
           </a:xfrm>
           <a:prstGeom prst="rect">
             <a:avLst/>
@@ -4301,7 +4764,7 @@
     <p:bg>
       <p:bgPr>
         <a:solidFill>
-          <a:srgbClr val="F8FAFC"/>
+          <a:srgbClr val="F7F9FB"/>
         </a:solidFill>
         <a:effectLst/>
       </p:bgPr>
@@ -4321,8 +4784,8 @@
         </p:nvSpPr>
         <p:spPr>
           <a:xfrm>
-            <a:off x="594360" y="320040"/>
-            <a:ext cx="8046720" cy="822960"/>
+            <a:off x="640080" y="411480"/>
+            <a:ext cx="9601200" cy="548640"/>
           </a:xfrm>
           <a:prstGeom prst="rect">
             <a:avLst/>
@@ -4330,19 +4793,24 @@
           <a:noFill/>
         </p:spPr>
         <p:txBody>
-          <a:bodyPr wrap="none">
+          <a:bodyPr wrap="square" anchor="t">
             <a:spAutoFit/>
           </a:bodyPr>
           <a:lstStyle/>
           <a:p>
-            <a:r>
-              <a:rPr b="1" sz="2500">
+            <a:pPr algn="l">
+              <a:lnSpc>
+                <a:spcPct val="120000"/>
+              </a:lnSpc>
+              <a:defRPr sz="2500" b="1">
                 <a:solidFill>
                   <a:srgbClr val="142C48"/>
                 </a:solidFill>
                 <a:latin typeface="Aptos Display"/>
-              </a:rPr>
-              <a:t>Betriebsverhalten und Kennwerte</a:t>
+              </a:defRPr>
+            </a:pPr>
+            <a:r>
+              <a:t>Betriebsverhalten und typische Kennwerte</a:t>
             </a:r>
           </a:p>
         </p:txBody>
@@ -4355,8 +4823,8 @@
         </p:nvSpPr>
         <p:spPr>
           <a:xfrm>
-            <a:off x="621792" y="914400"/>
-            <a:ext cx="7315200" cy="411480"/>
+            <a:off x="658368" y="868680"/>
+            <a:ext cx="9875520" cy="320040"/>
           </a:xfrm>
           <a:prstGeom prst="rect">
             <a:avLst/>
@@ -4364,25 +4832,31 @@
           <a:noFill/>
         </p:spPr>
         <p:txBody>
-          <a:bodyPr wrap="none">
+          <a:bodyPr wrap="square" anchor="t">
             <a:spAutoFit/>
           </a:bodyPr>
           <a:lstStyle/>
           <a:p>
-            <a:r>
-              <a:rPr sz="1200">
-                <a:solidFill>
-                  <a:srgbClr val="646F7E"/>
-                </a:solidFill>
-              </a:rPr>
-              <a:t>Leuchtstofflampen sind effizienter als Glühlampen, aber empfindlicher als LEDs.</a:t>
+            <a:pPr algn="l">
+              <a:lnSpc>
+                <a:spcPct val="120000"/>
+              </a:lnSpc>
+              <a:defRPr sz="1200" b="0">
+                <a:solidFill>
+                  <a:srgbClr val="63707C"/>
+                </a:solidFill>
+                <a:latin typeface="Aptos"/>
+              </a:defRPr>
+            </a:pPr>
+            <a:r>
+              <a:t>Worauf man im praktischen Einsatz achten muss</a:t>
             </a:r>
           </a:p>
         </p:txBody>
       </p:sp>
       <p:pic>
         <p:nvPicPr>
-          <p:cNvPr id="4" name="Picture 3" descr="vergleich.png"/>
+          <p:cNvPr id="4" name="Picture 3" descr="behavior_panel.png"/>
           <p:cNvPicPr>
             <a:picLocks noChangeAspect="1"/>
           </p:cNvPicPr>
@@ -4396,112 +4870,14 @@
         </p:blipFill>
         <p:spPr>
           <a:xfrm>
-            <a:off x="365760" y="1371600"/>
-            <a:ext cx="6492240" cy="4389120"/>
+            <a:off x="228600" y="1234440"/>
+            <a:ext cx="11750040" cy="5074920"/>
           </a:xfrm>
           <a:prstGeom prst="rect">
             <a:avLst/>
           </a:prstGeom>
         </p:spPr>
       </p:pic>
-      <p:sp>
-        <p:nvSpPr>
-          <p:cNvPr id="5" name="TextBox 4"/>
-          <p:cNvSpPr txBox="1"/>
-          <p:nvPr/>
-        </p:nvSpPr>
-        <p:spPr>
-          <a:xfrm>
-            <a:off x="7086600" y="1600200"/>
-            <a:ext cx="4572000" cy="4114800"/>
-          </a:xfrm>
-          <a:prstGeom prst="rect">
-            <a:avLst/>
-          </a:prstGeom>
-          <a:noFill/>
-        </p:spPr>
-        <p:txBody>
-          <a:bodyPr wrap="none">
-            <a:spAutoFit/>
-          </a:bodyPr>
-          <a:lstStyle/>
-          <a:p>
-            <a:pPr>
-              <a:spcAft>
-                <a:spcPts val="700"/>
-              </a:spcAft>
-              <a:defRPr sz="1500">
-                <a:solidFill>
-                  <a:srgbClr val="3A4653"/>
-                </a:solidFill>
-              </a:defRPr>
-            </a:pPr>
-            <a:r>
-              <a:t>kurze Anlaufzeit bis zur vollen Helligkeit</a:t>
-            </a:r>
-          </a:p>
-          <a:p>
-            <a:pPr>
-              <a:spcAft>
-                <a:spcPts val="700"/>
-              </a:spcAft>
-              <a:defRPr sz="1500">
-                <a:solidFill>
-                  <a:srgbClr val="3A4653"/>
-                </a:solidFill>
-              </a:defRPr>
-            </a:pPr>
-            <a:r>
-              <a:t>häufiges Schalten verkürzt die Lebensdauer</a:t>
-            </a:r>
-          </a:p>
-          <a:p>
-            <a:pPr>
-              <a:spcAft>
-                <a:spcPts val="700"/>
-              </a:spcAft>
-              <a:defRPr sz="1500">
-                <a:solidFill>
-                  <a:srgbClr val="3A4653"/>
-                </a:solidFill>
-              </a:defRPr>
-            </a:pPr>
-            <a:r>
-              <a:t>Temperatur beeinflusst Lichtstrom und Startverhalten</a:t>
-            </a:r>
-          </a:p>
-          <a:p>
-            <a:pPr>
-              <a:spcAft>
-                <a:spcPts val="700"/>
-              </a:spcAft>
-              <a:defRPr sz="1500">
-                <a:solidFill>
-                  <a:srgbClr val="3A4653"/>
-                </a:solidFill>
-              </a:defRPr>
-            </a:pPr>
-            <a:r>
-              <a:t>ältere Anlagen können flackern oder summen</a:t>
-            </a:r>
-          </a:p>
-          <a:p>
-            <a:pPr>
-              <a:spcAft>
-                <a:spcPts val="700"/>
-              </a:spcAft>
-              <a:defRPr sz="1500">
-                <a:solidFill>
-                  <a:srgbClr val="3A4653"/>
-                </a:solidFill>
-              </a:defRPr>
-            </a:pPr>
-            <a:r>
-              <a:t>elektronische Vorschaltgeräte verbessern Komfort und Effizienz</a:t>
-            </a:r>
-          </a:p>
-        </p:txBody>
-      </p:sp>
     </p:spTree>
   </p:cSld>
   <p:clrMapOvr>
@@ -4516,7 +4892,7 @@
     <p:bg>
       <p:bgPr>
         <a:solidFill>
-          <a:srgbClr val="F6F9FC"/>
+          <a:srgbClr val="F5F8FB"/>
         </a:solidFill>
         <a:effectLst/>
       </p:bgPr>
@@ -4536,8 +4912,8 @@
         </p:nvSpPr>
         <p:spPr>
           <a:xfrm>
-            <a:off x="594360" y="320040"/>
-            <a:ext cx="8046720" cy="822960"/>
+            <a:off x="640080" y="411480"/>
+            <a:ext cx="9601200" cy="548640"/>
           </a:xfrm>
           <a:prstGeom prst="rect">
             <a:avLst/>
@@ -4545,19 +4921,24 @@
           <a:noFill/>
         </p:spPr>
         <p:txBody>
-          <a:bodyPr wrap="none">
+          <a:bodyPr wrap="square" anchor="t">
             <a:spAutoFit/>
           </a:bodyPr>
           <a:lstStyle/>
           <a:p>
-            <a:r>
-              <a:rPr b="1" sz="2500">
+            <a:pPr algn="l">
+              <a:lnSpc>
+                <a:spcPct val="120000"/>
+              </a:lnSpc>
+              <a:defRPr sz="2500" b="1">
                 <a:solidFill>
                   <a:srgbClr val="142C48"/>
                 </a:solidFill>
                 <a:latin typeface="Aptos Display"/>
-              </a:rPr>
-              <a:t>Bauformen und Farbtemperaturen</a:t>
+              </a:defRPr>
+            </a:pPr>
+            <a:r>
+              <a:t>Bauformen, Ausführungen und Farbtemperaturen</a:t>
             </a:r>
           </a:p>
         </p:txBody>
@@ -4570,8 +4951,8 @@
         </p:nvSpPr>
         <p:spPr>
           <a:xfrm>
-            <a:off x="621792" y="914400"/>
-            <a:ext cx="7315200" cy="411480"/>
+            <a:off x="658368" y="868680"/>
+            <a:ext cx="9875520" cy="320040"/>
           </a:xfrm>
           <a:prstGeom prst="rect">
             <a:avLst/>
@@ -4579,25 +4960,31 @@
           <a:noFill/>
         </p:spPr>
         <p:txBody>
-          <a:bodyPr wrap="none">
+          <a:bodyPr wrap="square" anchor="t">
             <a:spAutoFit/>
           </a:bodyPr>
           <a:lstStyle/>
           <a:p>
-            <a:r>
-              <a:rPr sz="1200">
-                <a:solidFill>
-                  <a:srgbClr val="646F7E"/>
-                </a:solidFill>
-              </a:rPr>
-              <a:t>Typische Röhrenformen und Lichtfarben im Überblick</a:t>
+            <a:pPr algn="l">
+              <a:lnSpc>
+                <a:spcPct val="120000"/>
+              </a:lnSpc>
+              <a:defRPr sz="1200" b="0">
+                <a:solidFill>
+                  <a:srgbClr val="63707C"/>
+                </a:solidFill>
+                <a:latin typeface="Aptos"/>
+              </a:defRPr>
+            </a:pPr>
+            <a:r>
+              <a:t>Die Auswahl richtet sich nach Leuchte, Raum und Arbeitsaufgabe</a:t>
             </a:r>
           </a:p>
         </p:txBody>
       </p:sp>
       <p:pic>
         <p:nvPicPr>
-          <p:cNvPr id="4" name="Picture 3" descr="farben.png"/>
+          <p:cNvPr id="4" name="Picture 3" descr="forms_colors.png"/>
           <p:cNvPicPr>
             <a:picLocks noChangeAspect="1"/>
           </p:cNvPicPr>
@@ -4611,49 +4998,14 @@
         </p:blipFill>
         <p:spPr>
           <a:xfrm>
-            <a:off x="502920" y="1417320"/>
-            <a:ext cx="11155680" cy="4480560"/>
+            <a:off x="320040" y="1307592"/>
+            <a:ext cx="11567160" cy="4828032"/>
           </a:xfrm>
           <a:prstGeom prst="rect">
             <a:avLst/>
           </a:prstGeom>
         </p:spPr>
       </p:pic>
-      <p:sp>
-        <p:nvSpPr>
-          <p:cNvPr id="5" name="TextBox 4"/>
-          <p:cNvSpPr txBox="1"/>
-          <p:nvPr/>
-        </p:nvSpPr>
-        <p:spPr>
-          <a:xfrm>
-            <a:off x="731520" y="5806440"/>
-            <a:ext cx="10972800" cy="365760"/>
-          </a:xfrm>
-          <a:prstGeom prst="rect">
-            <a:avLst/>
-          </a:prstGeom>
-          <a:noFill/>
-        </p:spPr>
-        <p:txBody>
-          <a:bodyPr wrap="none">
-            <a:spAutoFit/>
-          </a:bodyPr>
-          <a:lstStyle/>
-          <a:p>
-            <a:pPr>
-              <a:defRPr sz="1300">
-                <a:solidFill>
-                  <a:srgbClr val="54606C"/>
-                </a:solidFill>
-              </a:defRPr>
-            </a:pPr>
-            <a:r>
-              <a:t>T8 ist der klassische Standard, T5 ist schlanker und meist effizienter. Die passende Lichtfarbe richtet sich nach Arbeitsaufgabe und Raumwirkung.</a:t>
-            </a:r>
-          </a:p>
-        </p:txBody>
-      </p:sp>
     </p:spTree>
   </p:cSld>
   <p:clrMapOvr>
@@ -4668,7 +5020,7 @@
     <p:bg>
       <p:bgPr>
         <a:solidFill>
-          <a:srgbClr val="121F34"/>
+          <a:srgbClr val="121F31"/>
         </a:solidFill>
         <a:effectLst/>
       </p:bgPr>
@@ -4688,8 +5040,8 @@
         </p:nvSpPr>
         <p:spPr>
           <a:xfrm>
-            <a:off x="594360" y="320040"/>
-            <a:ext cx="8046720" cy="822960"/>
+            <a:off x="640080" y="411480"/>
+            <a:ext cx="9601200" cy="548640"/>
           </a:xfrm>
           <a:prstGeom prst="rect">
             <a:avLst/>
@@ -4697,18 +5049,23 @@
           <a:noFill/>
         </p:spPr>
         <p:txBody>
-          <a:bodyPr wrap="none">
+          <a:bodyPr wrap="square" anchor="t">
             <a:spAutoFit/>
           </a:bodyPr>
           <a:lstStyle/>
           <a:p>
-            <a:r>
-              <a:rPr b="1" sz="2500">
+            <a:pPr algn="l">
+              <a:lnSpc>
+                <a:spcPct val="120000"/>
+              </a:lnSpc>
+              <a:defRPr sz="2500" b="1">
                 <a:solidFill>
                   <a:srgbClr val="FFFFFF"/>
                 </a:solidFill>
                 <a:latin typeface="Aptos Display"/>
-              </a:rPr>
+              </a:defRPr>
+            </a:pPr>
+            <a:r>
               <a:t>Typische Anwendungsbereiche</a:t>
             </a:r>
           </a:p>
@@ -4722,8 +5079,8 @@
         </p:nvSpPr>
         <p:spPr>
           <a:xfrm>
-            <a:off x="621792" y="914400"/>
-            <a:ext cx="7315200" cy="411480"/>
+            <a:off x="658368" y="868680"/>
+            <a:ext cx="9875520" cy="320040"/>
           </a:xfrm>
           <a:prstGeom prst="rect">
             <a:avLst/>
@@ -4731,25 +5088,31 @@
           <a:noFill/>
         </p:spPr>
         <p:txBody>
-          <a:bodyPr wrap="none">
+          <a:bodyPr wrap="square" anchor="t">
             <a:spAutoFit/>
           </a:bodyPr>
           <a:lstStyle/>
           <a:p>
-            <a:r>
-              <a:rPr sz="1200">
-                <a:solidFill>
-                  <a:srgbClr val="D7E8F5"/>
-                </a:solidFill>
-              </a:rPr>
-              <a:t>Wo Leuchtstofflampen besonders häufig eingesetzt wurden</a:t>
+            <a:pPr algn="l">
+              <a:lnSpc>
+                <a:spcPct val="120000"/>
+              </a:lnSpc>
+              <a:defRPr sz="1200" b="0">
+                <a:solidFill>
+                  <a:srgbClr val="D6E3ED"/>
+                </a:solidFill>
+                <a:latin typeface="Aptos"/>
+              </a:defRPr>
+            </a:pPr>
+            <a:r>
+              <a:t>Beispiele aus Schule, Büro, Werkstatt und Lagerhalle</a:t>
             </a:r>
           </a:p>
         </p:txBody>
       </p:sp>
       <p:pic>
         <p:nvPicPr>
-          <p:cNvPr id="4" name="Picture 3" descr="einsatz.png"/>
+          <p:cNvPr id="4" name="Picture 3" descr="applications.png"/>
           <p:cNvPicPr>
             <a:picLocks noChangeAspect="1"/>
           </p:cNvPicPr>
@@ -4763,8 +5126,8 @@
         </p:blipFill>
         <p:spPr>
           <a:xfrm>
-            <a:off x="411480" y="1325880"/>
-            <a:ext cx="11292840" cy="4480560"/>
+            <a:off x="201168" y="1234440"/>
+            <a:ext cx="11795760" cy="5138928"/>
           </a:xfrm>
           <a:prstGeom prst="rect">
             <a:avLst/>
@@ -4785,7 +5148,7 @@
     <p:bg>
       <p:bgPr>
         <a:solidFill>
-          <a:srgbClr val="F8FAFC"/>
+          <a:srgbClr val="F7F9FC"/>
         </a:solidFill>
         <a:effectLst/>
       </p:bgPr>
@@ -4805,8 +5168,8 @@
         </p:nvSpPr>
         <p:spPr>
           <a:xfrm>
-            <a:off x="594360" y="320040"/>
-            <a:ext cx="8046720" cy="822960"/>
+            <a:off x="640080" y="411480"/>
+            <a:ext cx="9601200" cy="548640"/>
           </a:xfrm>
           <a:prstGeom prst="rect">
             <a:avLst/>
@@ -4814,19 +5177,24 @@
           <a:noFill/>
         </p:spPr>
         <p:txBody>
-          <a:bodyPr wrap="none">
+          <a:bodyPr wrap="square" anchor="t">
             <a:spAutoFit/>
           </a:bodyPr>
           <a:lstStyle/>
           <a:p>
-            <a:r>
-              <a:rPr b="1" sz="2500">
+            <a:pPr algn="l">
+              <a:lnSpc>
+                <a:spcPct val="120000"/>
+              </a:lnSpc>
+              <a:defRPr sz="2500" b="1">
                 <a:solidFill>
                   <a:srgbClr val="142C48"/>
                 </a:solidFill>
                 <a:latin typeface="Aptos Display"/>
-              </a:rPr>
-              <a:t>Vor- und Nachteile</a:t>
+              </a:defRPr>
+            </a:pPr>
+            <a:r>
+              <a:t>Vorteile und Grenzen</a:t>
             </a:r>
           </a:p>
         </p:txBody>
@@ -4839,8 +5207,8 @@
         </p:nvSpPr>
         <p:spPr>
           <a:xfrm>
-            <a:off x="621792" y="914400"/>
-            <a:ext cx="7315200" cy="411480"/>
+            <a:off x="658368" y="868680"/>
+            <a:ext cx="9875520" cy="320040"/>
           </a:xfrm>
           <a:prstGeom prst="rect">
             <a:avLst/>
@@ -4848,18 +5216,24 @@
           <a:noFill/>
         </p:spPr>
         <p:txBody>
-          <a:bodyPr wrap="none">
+          <a:bodyPr wrap="square" anchor="t">
             <a:spAutoFit/>
           </a:bodyPr>
           <a:lstStyle/>
           <a:p>
-            <a:r>
-              <a:rPr sz="1200">
-                <a:solidFill>
-                  <a:srgbClr val="646F7E"/>
-                </a:solidFill>
-              </a:rPr>
-              <a:t>Die wichtigsten Argumente auf einen Blick</a:t>
+            <a:pPr algn="l">
+              <a:lnSpc>
+                <a:spcPct val="120000"/>
+              </a:lnSpc>
+              <a:defRPr sz="1200" b="0">
+                <a:solidFill>
+                  <a:srgbClr val="63707C"/>
+                </a:solidFill>
+                <a:latin typeface="Aptos"/>
+              </a:defRPr>
+            </a:pPr>
+            <a:r>
+              <a:t>Die Technik ist nachvollziehbar stark – hat aber klare Nachteile gegenüber LED</a:t>
             </a:r>
           </a:p>
         </p:txBody>
@@ -4872,8 +5246,8 @@
         </p:nvSpPr>
         <p:spPr>
           <a:xfrm>
-            <a:off x="822960" y="1554480"/>
-            <a:ext cx="4937760" cy="4023360"/>
+            <a:off x="822960" y="1572768"/>
+            <a:ext cx="5074920" cy="4434840"/>
           </a:xfrm>
           <a:prstGeom prst="roundRect">
             <a:avLst/>
@@ -4881,9 +5255,9 @@
           <a:solidFill>
             <a:srgbClr val="FFFFFF"/>
           </a:solidFill>
-          <a:ln w="31750">
+          <a:ln>
             <a:solidFill>
-              <a:srgbClr val="2EAA75"/>
+              <a:srgbClr val="43AB74"/>
             </a:solidFill>
           </a:ln>
         </p:spPr>
@@ -4911,109 +5285,14 @@
       </p:sp>
       <p:sp>
         <p:nvSpPr>
-          <p:cNvPr id="5" name="TextBox 4"/>
-          <p:cNvSpPr txBox="1"/>
-          <p:nvPr/>
-        </p:nvSpPr>
-        <p:spPr>
-          <a:xfrm>
-            <a:off x="1097280" y="1783080"/>
-            <a:ext cx="4389120" cy="3383280"/>
-          </a:xfrm>
-          <a:prstGeom prst="rect">
-            <a:avLst/>
-          </a:prstGeom>
-          <a:noFill/>
-        </p:spPr>
-        <p:txBody>
-          <a:bodyPr wrap="none">
-            <a:spAutoFit/>
-          </a:bodyPr>
-          <a:lstStyle/>
-          <a:p>
-            <a:pPr>
-              <a:defRPr sz="2400" b="1">
-                <a:solidFill>
-                  <a:srgbClr val="2EAA75"/>
-                </a:solidFill>
-              </a:defRPr>
-            </a:pPr>
-            <a:r>
-              <a:t>Vorteile</a:t>
-            </a:r>
-          </a:p>
-          <a:p>
-            <a:pPr>
-              <a:spcAft>
-                <a:spcPts val="700"/>
-              </a:spcAft>
-              <a:defRPr sz="1600">
-                <a:solidFill>
-                  <a:srgbClr val="3A4653"/>
-                </a:solidFill>
-              </a:defRPr>
-            </a:pPr>
-            <a:r>
-              <a:t>gute Lichtausbeute</a:t>
-            </a:r>
-          </a:p>
-          <a:p>
-            <a:pPr>
-              <a:spcAft>
-                <a:spcPts val="700"/>
-              </a:spcAft>
-              <a:defRPr sz="1600">
-                <a:solidFill>
-                  <a:srgbClr val="3A4653"/>
-                </a:solidFill>
-              </a:defRPr>
-            </a:pPr>
-            <a:r>
-              <a:t>großflächige, gleichmäßige Ausleuchtung</a:t>
-            </a:r>
-          </a:p>
-          <a:p>
-            <a:pPr>
-              <a:spcAft>
-                <a:spcPts val="700"/>
-              </a:spcAft>
-              <a:defRPr sz="1600">
-                <a:solidFill>
-                  <a:srgbClr val="3A4653"/>
-                </a:solidFill>
-              </a:defRPr>
-            </a:pPr>
-            <a:r>
-              <a:t>verschiedene Lichtfarben verfügbar</a:t>
-            </a:r>
-          </a:p>
-          <a:p>
-            <a:pPr>
-              <a:spcAft>
-                <a:spcPts val="700"/>
-              </a:spcAft>
-              <a:defRPr sz="1600">
-                <a:solidFill>
-                  <a:srgbClr val="3A4653"/>
-                </a:solidFill>
-              </a:defRPr>
-            </a:pPr>
-            <a:r>
-              <a:t>lange Zeit wirtschaftlicher Standard</a:t>
-            </a:r>
-          </a:p>
-        </p:txBody>
-      </p:sp>
-      <p:sp>
-        <p:nvSpPr>
-          <p:cNvPr id="6" name="Rounded Rectangle 5"/>
+          <p:cNvPr id="5" name="Rounded Rectangle 4"/>
           <p:cNvSpPr/>
           <p:nvPr/>
         </p:nvSpPr>
         <p:spPr>
           <a:xfrm>
-            <a:off x="6492240" y="1554480"/>
-            <a:ext cx="4937760" cy="4023360"/>
+            <a:off x="6263640" y="1572768"/>
+            <a:ext cx="5074920" cy="4434840"/>
           </a:xfrm>
           <a:prstGeom prst="roundRect">
             <a:avLst/>
@@ -5021,9 +5300,9 @@
           <a:solidFill>
             <a:srgbClr val="FFFFFF"/>
           </a:solidFill>
-          <a:ln w="31750">
+          <a:ln>
             <a:solidFill>
-              <a:srgbClr val="DF5757"/>
+              <a:srgbClr val="D65F5F"/>
             </a:solidFill>
           </a:ln>
         </p:spPr>
@@ -5051,14 +5330,14 @@
       </p:sp>
       <p:sp>
         <p:nvSpPr>
-          <p:cNvPr id="7" name="TextBox 6"/>
+          <p:cNvPr id="6" name="TextBox 5"/>
           <p:cNvSpPr txBox="1"/>
           <p:nvPr/>
         </p:nvSpPr>
         <p:spPr>
           <a:xfrm>
-            <a:off x="6766560" y="1783080"/>
-            <a:ext cx="4389120" cy="3383280"/>
+            <a:off x="1097280" y="1828800"/>
+            <a:ext cx="2194560" cy="320040"/>
           </a:xfrm>
           <a:prstGeom prst="rect">
             <a:avLst/>
@@ -5066,80 +5345,261 @@
           <a:noFill/>
         </p:spPr>
         <p:txBody>
-          <a:bodyPr wrap="none">
+          <a:bodyPr wrap="square" anchor="t">
             <a:spAutoFit/>
           </a:bodyPr>
           <a:lstStyle/>
           <a:p>
+            <a:pPr algn="l">
+              <a:lnSpc>
+                <a:spcPct val="120000"/>
+              </a:lnSpc>
+              <a:defRPr sz="2300" b="1">
+                <a:solidFill>
+                  <a:srgbClr val="43AB74"/>
+                </a:solidFill>
+                <a:latin typeface="Aptos"/>
+              </a:defRPr>
+            </a:pPr>
+            <a:r>
+              <a:t>Vorteile</a:t>
+            </a:r>
+          </a:p>
+        </p:txBody>
+      </p:sp>
+      <p:sp>
+        <p:nvSpPr>
+          <p:cNvPr id="7" name="TextBox 6"/>
+          <p:cNvSpPr txBox="1"/>
+          <p:nvPr/>
+        </p:nvSpPr>
+        <p:spPr>
+          <a:xfrm>
+            <a:off x="1078992" y="2240280"/>
+            <a:ext cx="4389120" cy="1865376"/>
+          </a:xfrm>
+          <a:prstGeom prst="rect">
+            <a:avLst/>
+          </a:prstGeom>
+          <a:noFill/>
+        </p:spPr>
+        <p:txBody>
+          <a:bodyPr wrap="square">
+            <a:spAutoFit/>
+          </a:bodyPr>
+          <a:lstStyle/>
+          <a:p>
             <a:pPr>
-              <a:defRPr sz="2400" b="1">
-                <a:solidFill>
-                  <a:srgbClr val="DF5757"/>
-                </a:solidFill>
-              </a:defRPr>
-            </a:pPr>
-            <a:r>
-              <a:t>Nachteile</a:t>
-            </a:r>
-          </a:p>
-          <a:p>
-            <a:pPr>
+              <a:lnSpc>
+                <a:spcPct val="115000"/>
+              </a:lnSpc>
               <a:spcAft>
-                <a:spcPts val="700"/>
+                <a:spcPts val="400"/>
               </a:spcAft>
               <a:defRPr sz="1600">
                 <a:solidFill>
-                  <a:srgbClr val="3A4653"/>
-                </a:solidFill>
+                  <a:srgbClr val="3C4854"/>
+                </a:solidFill>
+                <a:latin typeface="Aptos"/>
               </a:defRPr>
             </a:pPr>
             <a:r>
-              <a:t>enthält Quecksilber</a:t>
+              <a:t>• gute Lichtausbeute gegenüber klassischen Glühlampen</a:t>
             </a:r>
           </a:p>
           <a:p>
             <a:pPr>
+              <a:lnSpc>
+                <a:spcPct val="115000"/>
+              </a:lnSpc>
               <a:spcAft>
-                <a:spcPts val="700"/>
+                <a:spcPts val="400"/>
               </a:spcAft>
               <a:defRPr sz="1600">
                 <a:solidFill>
-                  <a:srgbClr val="3A4653"/>
-                </a:solidFill>
+                  <a:srgbClr val="3C4854"/>
+                </a:solidFill>
+                <a:latin typeface="Aptos"/>
               </a:defRPr>
             </a:pPr>
             <a:r>
-              <a:t>Anlaufzeit bis volle Helligkeit</a:t>
+              <a:t>• gleichmäßige und breite Ausleuchtung</a:t>
             </a:r>
           </a:p>
           <a:p>
             <a:pPr>
+              <a:lnSpc>
+                <a:spcPct val="115000"/>
+              </a:lnSpc>
               <a:spcAft>
-                <a:spcPts val="700"/>
+                <a:spcPts val="400"/>
               </a:spcAft>
               <a:defRPr sz="1600">
                 <a:solidFill>
-                  <a:srgbClr val="3A4653"/>
-                </a:solidFill>
+                  <a:srgbClr val="3C4854"/>
+                </a:solidFill>
+                <a:latin typeface="Aptos"/>
               </a:defRPr>
             </a:pPr>
             <a:r>
-              <a:t>empfindlich bei häufigem Schalten</a:t>
+              <a:t>• verschiedene Lichtfarben möglich</a:t>
             </a:r>
           </a:p>
           <a:p>
             <a:pPr>
+              <a:lnSpc>
+                <a:spcPct val="115000"/>
+              </a:lnSpc>
               <a:spcAft>
-                <a:spcPts val="700"/>
+                <a:spcPts val="400"/>
               </a:spcAft>
               <a:defRPr sz="1600">
                 <a:solidFill>
-                  <a:srgbClr val="3A4653"/>
-                </a:solidFill>
+                  <a:srgbClr val="3C4854"/>
+                </a:solidFill>
+                <a:latin typeface="Aptos"/>
               </a:defRPr>
             </a:pPr>
             <a:r>
-              <a:t>heute oft LED technisch unterlegen</a:t>
+              <a:t>• für große Räume lange wirtschaftlich sinnvoll</a:t>
+            </a:r>
+          </a:p>
+        </p:txBody>
+      </p:sp>
+      <p:sp>
+        <p:nvSpPr>
+          <p:cNvPr id="8" name="TextBox 7"/>
+          <p:cNvSpPr txBox="1"/>
+          <p:nvPr/>
+        </p:nvSpPr>
+        <p:spPr>
+          <a:xfrm>
+            <a:off x="6537960" y="1828800"/>
+            <a:ext cx="2377440" cy="320040"/>
+          </a:xfrm>
+          <a:prstGeom prst="rect">
+            <a:avLst/>
+          </a:prstGeom>
+          <a:noFill/>
+        </p:spPr>
+        <p:txBody>
+          <a:bodyPr wrap="square" anchor="t">
+            <a:spAutoFit/>
+          </a:bodyPr>
+          <a:lstStyle/>
+          <a:p>
+            <a:pPr algn="l">
+              <a:lnSpc>
+                <a:spcPct val="120000"/>
+              </a:lnSpc>
+              <a:defRPr sz="2300" b="1">
+                <a:solidFill>
+                  <a:srgbClr val="D65F5F"/>
+                </a:solidFill>
+                <a:latin typeface="Aptos"/>
+              </a:defRPr>
+            </a:pPr>
+            <a:r>
+              <a:t>Nachteile</a:t>
+            </a:r>
+          </a:p>
+        </p:txBody>
+      </p:sp>
+      <p:sp>
+        <p:nvSpPr>
+          <p:cNvPr id="9" name="TextBox 8"/>
+          <p:cNvSpPr txBox="1"/>
+          <p:nvPr/>
+        </p:nvSpPr>
+        <p:spPr>
+          <a:xfrm>
+            <a:off x="6519672" y="2240280"/>
+            <a:ext cx="4389120" cy="1865376"/>
+          </a:xfrm>
+          <a:prstGeom prst="rect">
+            <a:avLst/>
+          </a:prstGeom>
+          <a:noFill/>
+        </p:spPr>
+        <p:txBody>
+          <a:bodyPr wrap="square">
+            <a:spAutoFit/>
+          </a:bodyPr>
+          <a:lstStyle/>
+          <a:p>
+            <a:pPr>
+              <a:lnSpc>
+                <a:spcPct val="115000"/>
+              </a:lnSpc>
+              <a:spcAft>
+                <a:spcPts val="400"/>
+              </a:spcAft>
+              <a:defRPr sz="1600">
+                <a:solidFill>
+                  <a:srgbClr val="3C4854"/>
+                </a:solidFill>
+                <a:latin typeface="Aptos"/>
+              </a:defRPr>
+            </a:pPr>
+            <a:r>
+              <a:t>• enthält Quecksilber und ist damit entsorgungspflichtig</a:t>
+            </a:r>
+          </a:p>
+          <a:p>
+            <a:pPr>
+              <a:lnSpc>
+                <a:spcPct val="115000"/>
+              </a:lnSpc>
+              <a:spcAft>
+                <a:spcPts val="400"/>
+              </a:spcAft>
+              <a:defRPr sz="1600">
+                <a:solidFill>
+                  <a:srgbClr val="3C4854"/>
+                </a:solidFill>
+                <a:latin typeface="Aptos"/>
+              </a:defRPr>
+            </a:pPr>
+            <a:r>
+              <a:t>• braucht oft kurze Anlaufzeit bis zur vollen Helligkeit</a:t>
+            </a:r>
+          </a:p>
+          <a:p>
+            <a:pPr>
+              <a:lnSpc>
+                <a:spcPct val="115000"/>
+              </a:lnSpc>
+              <a:spcAft>
+                <a:spcPts val="400"/>
+              </a:spcAft>
+              <a:defRPr sz="1600">
+                <a:solidFill>
+                  <a:srgbClr val="3C4854"/>
+                </a:solidFill>
+                <a:latin typeface="Aptos"/>
+              </a:defRPr>
+            </a:pPr>
+            <a:r>
+              <a:t>• häufiges Schalten verkürzt die Lebensdauer</a:t>
+            </a:r>
+          </a:p>
+          <a:p>
+            <a:pPr>
+              <a:lnSpc>
+                <a:spcPct val="115000"/>
+              </a:lnSpc>
+              <a:spcAft>
+                <a:spcPts val="400"/>
+              </a:spcAft>
+              <a:defRPr sz="1600">
+                <a:solidFill>
+                  <a:srgbClr val="3C4854"/>
+                </a:solidFill>
+                <a:latin typeface="Aptos"/>
+              </a:defRPr>
+            </a:pPr>
+            <a:r>
+              <a:t>• heute in vielen Bereichen technisch von LEDs übertroffen</a:t>
             </a:r>
           </a:p>
         </p:txBody>
@@ -5158,7 +5618,7 @@
     <p:bg>
       <p:bgPr>
         <a:solidFill>
-          <a:srgbClr val="F7FAF8"/>
+          <a:srgbClr val="F6F8F7"/>
         </a:solidFill>
         <a:effectLst/>
       </p:bgPr>
@@ -5178,8 +5638,8 @@
         </p:nvSpPr>
         <p:spPr>
           <a:xfrm>
-            <a:off x="594360" y="320040"/>
-            <a:ext cx="8046720" cy="822960"/>
+            <a:off x="640080" y="411480"/>
+            <a:ext cx="9601200" cy="548640"/>
           </a:xfrm>
           <a:prstGeom prst="rect">
             <a:avLst/>
@@ -5187,19 +5647,24 @@
           <a:noFill/>
         </p:spPr>
         <p:txBody>
-          <a:bodyPr wrap="none">
+          <a:bodyPr wrap="square" anchor="t">
             <a:spAutoFit/>
           </a:bodyPr>
           <a:lstStyle/>
           <a:p>
-            <a:r>
-              <a:rPr b="1" sz="2500">
+            <a:pPr algn="l">
+              <a:lnSpc>
+                <a:spcPct val="120000"/>
+              </a:lnSpc>
+              <a:defRPr sz="2500" b="1">
                 <a:solidFill>
                   <a:srgbClr val="142C48"/>
                 </a:solidFill>
                 <a:latin typeface="Aptos Display"/>
-              </a:rPr>
-              <a:t>Besonderheiten: Umwelt und Entsorgung</a:t>
+              </a:defRPr>
+            </a:pPr>
+            <a:r>
+              <a:t>Besonderheiten: Umwelt, Entsorgung und heutige Bedeutung</a:t>
             </a:r>
           </a:p>
         </p:txBody>
@@ -5212,8 +5677,8 @@
         </p:nvSpPr>
         <p:spPr>
           <a:xfrm>
-            <a:off x="621792" y="914400"/>
-            <a:ext cx="7315200" cy="411480"/>
+            <a:off x="658368" y="868680"/>
+            <a:ext cx="9875520" cy="320040"/>
           </a:xfrm>
           <a:prstGeom prst="rect">
             <a:avLst/>
@@ -5221,25 +5686,31 @@
           <a:noFill/>
         </p:spPr>
         <p:txBody>
-          <a:bodyPr wrap="none">
+          <a:bodyPr wrap="square" anchor="t">
             <a:spAutoFit/>
           </a:bodyPr>
           <a:lstStyle/>
           <a:p>
-            <a:r>
-              <a:rPr sz="1200">
-                <a:solidFill>
-                  <a:srgbClr val="646F7E"/>
-                </a:solidFill>
-              </a:rPr>
-              <a:t>Der Umgang mit Leuchtstofflampen verlangt Sorgfalt.</a:t>
+            <a:pPr algn="l">
+              <a:lnSpc>
+                <a:spcPct val="120000"/>
+              </a:lnSpc>
+              <a:defRPr sz="1200" b="0">
+                <a:solidFill>
+                  <a:srgbClr val="63707C"/>
+                </a:solidFill>
+                <a:latin typeface="Aptos"/>
+              </a:defRPr>
+            </a:pPr>
+            <a:r>
+              <a:t>Wichtige Hinweise für den sicheren und fachgerechten Umgang</a:t>
             </a:r>
           </a:p>
         </p:txBody>
       </p:sp>
       <p:pic>
         <p:nvPicPr>
-          <p:cNvPr id="4" name="Picture 3" descr="umwelt.png"/>
+          <p:cNvPr id="4" name="Picture 3" descr="environment.png"/>
           <p:cNvPicPr>
             <a:picLocks noChangeAspect="1"/>
           </p:cNvPicPr>
@@ -5253,8 +5724,8 @@
         </p:blipFill>
         <p:spPr>
           <a:xfrm>
-            <a:off x="411480" y="1325880"/>
-            <a:ext cx="11292840" cy="4526280"/>
+            <a:off x="274320" y="1316736"/>
+            <a:ext cx="11658600" cy="4892040"/>
           </a:xfrm>
           <a:prstGeom prst="rect">
             <a:avLst/>

</xml_diff>

<commit_message>
Rebuild presentation with fixed slide layouts
Co-authored-by: tom948899-jpg <300044775+tom948899-jpg@users.noreply.github.com>
</commit_message>
<xml_diff>
--- a/Leuchtstofflampen_Praesentation.pptx
+++ b/Leuchtstofflampen_Praesentation.pptx
@@ -3090,14 +3090,6 @@
 <file path=ppt/slides/slide1.xml><?xml version="1.0" encoding="utf-8"?>
 <p:sld xmlns:a="http://schemas.openxmlformats.org/drawingml/2006/main" xmlns:p="http://schemas.openxmlformats.org/presentationml/2006/main" xmlns:r="http://schemas.openxmlformats.org/officeDocument/2006/relationships">
   <p:cSld>
-    <p:bg>
-      <p:bgPr>
-        <a:solidFill>
-          <a:srgbClr val="0E192B"/>
-        </a:solidFill>
-        <a:effectLst/>
-      </p:bgPr>
-    </p:bg>
     <p:spTree>
       <p:nvGrpSpPr>
         <p:cNvPr id="1" name=""/>
@@ -3107,7 +3099,7 @@
       <p:grpSpPr/>
       <p:pic>
         <p:nvPicPr>
-          <p:cNvPr id="2" name="Picture 1" descr="title_scene.png"/>
+          <p:cNvPr id="2" name="Picture 1" descr="slide1.jpg"/>
           <p:cNvPicPr>
             <a:picLocks noChangeAspect="1"/>
           </p:cNvPicPr>
@@ -3129,45 +3121,6 @@
           </a:prstGeom>
         </p:spPr>
       </p:pic>
-      <p:sp>
-        <p:nvSpPr>
-          <p:cNvPr id="3" name="TextBox 2"/>
-          <p:cNvSpPr txBox="1"/>
-          <p:nvPr/>
-        </p:nvSpPr>
-        <p:spPr>
-          <a:xfrm>
-            <a:off x="749808" y="6291072"/>
-            <a:ext cx="3931920" cy="228600"/>
-          </a:xfrm>
-          <a:prstGeom prst="rect">
-            <a:avLst/>
-          </a:prstGeom>
-          <a:noFill/>
-        </p:spPr>
-        <p:txBody>
-          <a:bodyPr wrap="square" anchor="t">
-            <a:spAutoFit/>
-          </a:bodyPr>
-          <a:lstStyle/>
-          <a:p>
-            <a:pPr algn="l">
-              <a:lnSpc>
-                <a:spcPct val="120000"/>
-              </a:lnSpc>
-              <a:defRPr sz="1100" b="0">
-                <a:solidFill>
-                  <a:srgbClr val="CEDCE8"/>
-                </a:solidFill>
-                <a:latin typeface="Aptos"/>
-              </a:defRPr>
-            </a:pPr>
-            <a:r>
-              <a:t>Name · Klasse · Datum ergänzen</a:t>
-            </a:r>
-          </a:p>
-        </p:txBody>
-      </p:sp>
     </p:spTree>
   </p:cSld>
   <p:clrMapOvr>
@@ -3179,14 +3132,6 @@
 <file path=ppt/slides/slide10.xml><?xml version="1.0" encoding="utf-8"?>
 <p:sld xmlns:a="http://schemas.openxmlformats.org/drawingml/2006/main" xmlns:p="http://schemas.openxmlformats.org/presentationml/2006/main" xmlns:r="http://schemas.openxmlformats.org/officeDocument/2006/relationships">
   <p:cSld>
-    <p:bg>
-      <p:bgPr>
-        <a:solidFill>
-          <a:srgbClr val="0A1627"/>
-        </a:solidFill>
-        <a:effectLst/>
-      </p:bgPr>
-    </p:bg>
     <p:spTree>
       <p:nvGrpSpPr>
         <p:cNvPr id="1" name=""/>
@@ -3194,1295 +3139,9 @@
         <p:nvPr/>
       </p:nvGrpSpPr>
       <p:grpSpPr/>
-      <p:sp>
-        <p:nvSpPr>
-          <p:cNvPr id="2" name="TextBox 1"/>
-          <p:cNvSpPr txBox="1"/>
-          <p:nvPr/>
-        </p:nvSpPr>
-        <p:spPr>
-          <a:xfrm>
-            <a:off x="640080" y="411480"/>
-            <a:ext cx="9601200" cy="548640"/>
-          </a:xfrm>
-          <a:prstGeom prst="rect">
-            <a:avLst/>
-          </a:prstGeom>
-          <a:noFill/>
-        </p:spPr>
-        <p:txBody>
-          <a:bodyPr wrap="square" anchor="t">
-            <a:spAutoFit/>
-          </a:bodyPr>
-          <a:lstStyle/>
-          <a:p>
-            <a:pPr algn="l">
-              <a:lnSpc>
-                <a:spcPct val="120000"/>
-              </a:lnSpc>
-              <a:defRPr sz="2500" b="1">
-                <a:solidFill>
-                  <a:srgbClr val="FFFFFF"/>
-                </a:solidFill>
-                <a:latin typeface="Aptos Display"/>
-              </a:defRPr>
-            </a:pPr>
-            <a:r>
-              <a:t>Fazit</a:t>
-            </a:r>
-          </a:p>
-        </p:txBody>
-      </p:sp>
-      <p:sp>
-        <p:nvSpPr>
-          <p:cNvPr id="3" name="TextBox 2"/>
-          <p:cNvSpPr txBox="1"/>
-          <p:nvPr/>
-        </p:nvSpPr>
-        <p:spPr>
-          <a:xfrm>
-            <a:off x="658368" y="868680"/>
-            <a:ext cx="9875520" cy="320040"/>
-          </a:xfrm>
-          <a:prstGeom prst="rect">
-            <a:avLst/>
-          </a:prstGeom>
-          <a:noFill/>
-        </p:spPr>
-        <p:txBody>
-          <a:bodyPr wrap="square" anchor="t">
-            <a:spAutoFit/>
-          </a:bodyPr>
-          <a:lstStyle/>
-          <a:p>
-            <a:pPr algn="l">
-              <a:lnSpc>
-                <a:spcPct val="120000"/>
-              </a:lnSpc>
-              <a:defRPr sz="1200" b="0">
-                <a:solidFill>
-                  <a:srgbClr val="D6E3ED"/>
-                </a:solidFill>
-                <a:latin typeface="Aptos"/>
-              </a:defRPr>
-            </a:pPr>
-            <a:r>
-              <a:t>Kurz und verständlich zusammengefasst</a:t>
-            </a:r>
-          </a:p>
-        </p:txBody>
-      </p:sp>
-      <p:sp>
-        <p:nvSpPr>
-          <p:cNvPr id="4" name="TextBox 3"/>
-          <p:cNvSpPr txBox="1"/>
-          <p:nvPr/>
-        </p:nvSpPr>
-        <p:spPr>
-          <a:xfrm>
-            <a:off x="914400" y="1508760"/>
-            <a:ext cx="10332720" cy="731520"/>
-          </a:xfrm>
-          <a:prstGeom prst="rect">
-            <a:avLst/>
-          </a:prstGeom>
-          <a:noFill/>
-        </p:spPr>
-        <p:txBody>
-          <a:bodyPr wrap="square" anchor="t">
-            <a:spAutoFit/>
-          </a:bodyPr>
-          <a:lstStyle/>
-          <a:p>
-            <a:pPr algn="ctr">
-              <a:lnSpc>
-                <a:spcPct val="120000"/>
-              </a:lnSpc>
-              <a:defRPr sz="2200" b="0">
-                <a:solidFill>
-                  <a:srgbClr val="F1F6FA"/>
-                </a:solidFill>
-                <a:latin typeface="Aptos"/>
-              </a:defRPr>
-            </a:pPr>
-            <a:r>
-              <a:t>Leuchtstofflampen waren über viele Jahre die Standardlösung für große Innenräume.</a:t>
-            </a:r>
-          </a:p>
-          <a:p>
-            <a:pPr>
-              <a:lnSpc>
-                <a:spcPct val="120000"/>
-              </a:lnSpc>
-              <a:defRPr sz="2200" b="0">
-                <a:solidFill>
-                  <a:srgbClr val="F1F6FA"/>
-                </a:solidFill>
-                <a:latin typeface="Aptos"/>
-              </a:defRPr>
-            </a:pPr>
-            <a:r>
-              <a:t>Technisch sind sie interessant, heute werden sie jedoch meist durch LED-Systeme ersetzt.</a:t>
-            </a:r>
-          </a:p>
-        </p:txBody>
-      </p:sp>
-      <p:sp>
-        <p:nvSpPr>
-          <p:cNvPr id="5" name="Rounded Rectangle 4"/>
-          <p:cNvSpPr/>
-          <p:nvPr/>
-        </p:nvSpPr>
-        <p:spPr>
-          <a:xfrm>
-            <a:off x="822960" y="2880360"/>
-            <a:ext cx="3246120" cy="2011680"/>
-          </a:xfrm>
-          <a:prstGeom prst="roundRect">
-            <a:avLst/>
-          </a:prstGeom>
-          <a:solidFill>
-            <a:srgbClr val="FFFFFF"/>
-          </a:solidFill>
-          <a:ln>
-            <a:solidFill>
-              <a:srgbClr val="57B8E8"/>
-            </a:solidFill>
-          </a:ln>
-        </p:spPr>
-        <p:style>
-          <a:lnRef idx="1">
-            <a:schemeClr val="accent1"/>
-          </a:lnRef>
-          <a:fillRef idx="3">
-            <a:schemeClr val="accent1"/>
-          </a:fillRef>
-          <a:effectRef idx="2">
-            <a:schemeClr val="accent1"/>
-          </a:effectRef>
-          <a:fontRef idx="minor">
-            <a:schemeClr val="lt1"/>
-          </a:fontRef>
-        </p:style>
-        <p:txBody>
-          <a:bodyPr rtlCol="0" anchor="ctr"/>
-          <a:lstStyle/>
-          <a:p>
-            <a:pPr algn="ctr"/>
-          </a:p>
-        </p:txBody>
-      </p:sp>
-      <p:sp>
-        <p:nvSpPr>
-          <p:cNvPr id="6" name="TextBox 5"/>
-          <p:cNvSpPr txBox="1"/>
-          <p:nvPr/>
-        </p:nvSpPr>
-        <p:spPr>
-          <a:xfrm>
-            <a:off x="987552" y="3108960"/>
-            <a:ext cx="2834640" cy="292608"/>
-          </a:xfrm>
-          <a:prstGeom prst="rect">
-            <a:avLst/>
-          </a:prstGeom>
-          <a:noFill/>
-        </p:spPr>
-        <p:txBody>
-          <a:bodyPr wrap="square" anchor="t">
-            <a:spAutoFit/>
-          </a:bodyPr>
-          <a:lstStyle/>
-          <a:p>
-            <a:pPr algn="l">
-              <a:lnSpc>
-                <a:spcPct val="120000"/>
-              </a:lnSpc>
-              <a:defRPr sz="1900" b="1">
-                <a:solidFill>
-                  <a:srgbClr val="57D6FF"/>
-                </a:solidFill>
-                <a:latin typeface="Aptos"/>
-              </a:defRPr>
-            </a:pPr>
-            <a:r>
-              <a:t>Aufbau</a:t>
-            </a:r>
-          </a:p>
-        </p:txBody>
-      </p:sp>
-      <p:sp>
-        <p:nvSpPr>
-          <p:cNvPr id="7" name="TextBox 6"/>
-          <p:cNvSpPr txBox="1"/>
-          <p:nvPr/>
-        </p:nvSpPr>
-        <p:spPr>
-          <a:xfrm>
-            <a:off x="987552" y="3493008"/>
-            <a:ext cx="2880360" cy="1005840"/>
-          </a:xfrm>
-          <a:prstGeom prst="rect">
-            <a:avLst/>
-          </a:prstGeom>
-          <a:noFill/>
-        </p:spPr>
-        <p:txBody>
-          <a:bodyPr wrap="square" anchor="t">
-            <a:spAutoFit/>
-          </a:bodyPr>
-          <a:lstStyle/>
-          <a:p>
-            <a:pPr algn="l">
-              <a:lnSpc>
-                <a:spcPct val="120000"/>
-              </a:lnSpc>
-              <a:defRPr sz="1400" b="0">
-                <a:solidFill>
-                  <a:srgbClr val="E2ECF4"/>
-                </a:solidFill>
-                <a:latin typeface="Aptos"/>
-              </a:defRPr>
-            </a:pPr>
-            <a:r>
-              <a:t>Gasfüllung, Elektroden, Leuchtstoffschicht und Vorschaltgerät arbeiten zusammen.</a:t>
-            </a:r>
-          </a:p>
-        </p:txBody>
-      </p:sp>
-      <p:sp>
-        <p:nvSpPr>
-          <p:cNvPr id="8" name="Rounded Rectangle 7"/>
-          <p:cNvSpPr/>
-          <p:nvPr/>
-        </p:nvSpPr>
-        <p:spPr>
-          <a:xfrm>
-            <a:off x="4572000" y="2880360"/>
-            <a:ext cx="3246120" cy="2011680"/>
-          </a:xfrm>
-          <a:prstGeom prst="roundRect">
-            <a:avLst/>
-          </a:prstGeom>
-          <a:solidFill>
-            <a:srgbClr val="FFFFFF"/>
-          </a:solidFill>
-          <a:ln>
-            <a:solidFill>
-              <a:srgbClr val="57B8E8"/>
-            </a:solidFill>
-          </a:ln>
-        </p:spPr>
-        <p:style>
-          <a:lnRef idx="1">
-            <a:schemeClr val="accent1"/>
-          </a:lnRef>
-          <a:fillRef idx="3">
-            <a:schemeClr val="accent1"/>
-          </a:fillRef>
-          <a:effectRef idx="2">
-            <a:schemeClr val="accent1"/>
-          </a:effectRef>
-          <a:fontRef idx="minor">
-            <a:schemeClr val="lt1"/>
-          </a:fontRef>
-        </p:style>
-        <p:txBody>
-          <a:bodyPr rtlCol="0" anchor="ctr"/>
-          <a:lstStyle/>
-          <a:p>
-            <a:pPr algn="ctr"/>
-          </a:p>
-        </p:txBody>
-      </p:sp>
-      <p:sp>
-        <p:nvSpPr>
-          <p:cNvPr id="9" name="TextBox 8"/>
-          <p:cNvSpPr txBox="1"/>
-          <p:nvPr/>
-        </p:nvSpPr>
-        <p:spPr>
-          <a:xfrm>
-            <a:off x="4736592" y="3108960"/>
-            <a:ext cx="2834640" cy="292608"/>
-          </a:xfrm>
-          <a:prstGeom prst="rect">
-            <a:avLst/>
-          </a:prstGeom>
-          <a:noFill/>
-        </p:spPr>
-        <p:txBody>
-          <a:bodyPr wrap="square" anchor="t">
-            <a:spAutoFit/>
-          </a:bodyPr>
-          <a:lstStyle/>
-          <a:p>
-            <a:pPr algn="l">
-              <a:lnSpc>
-                <a:spcPct val="120000"/>
-              </a:lnSpc>
-              <a:defRPr sz="1900" b="1">
-                <a:solidFill>
-                  <a:srgbClr val="57D6FF"/>
-                </a:solidFill>
-                <a:latin typeface="Aptos"/>
-              </a:defRPr>
-            </a:pPr>
-            <a:r>
-              <a:t>Praxis</a:t>
-            </a:r>
-          </a:p>
-        </p:txBody>
-      </p:sp>
-      <p:sp>
-        <p:nvSpPr>
-          <p:cNvPr id="10" name="TextBox 9"/>
-          <p:cNvSpPr txBox="1"/>
-          <p:nvPr/>
-        </p:nvSpPr>
-        <p:spPr>
-          <a:xfrm>
-            <a:off x="4736592" y="3493008"/>
-            <a:ext cx="2880360" cy="1005840"/>
-          </a:xfrm>
-          <a:prstGeom prst="rect">
-            <a:avLst/>
-          </a:prstGeom>
-          <a:noFill/>
-        </p:spPr>
-        <p:txBody>
-          <a:bodyPr wrap="square" anchor="t">
-            <a:spAutoFit/>
-          </a:bodyPr>
-          <a:lstStyle/>
-          <a:p>
-            <a:pPr algn="l">
-              <a:lnSpc>
-                <a:spcPct val="120000"/>
-              </a:lnSpc>
-              <a:defRPr sz="1400" b="0">
-                <a:solidFill>
-                  <a:srgbClr val="E2ECF4"/>
-                </a:solidFill>
-                <a:latin typeface="Aptos"/>
-              </a:defRPr>
-            </a:pPr>
-            <a:r>
-              <a:t>Besonders geeignet bei längeren Brennzeiten und gleichmäßiger Raumausleuchtung.</a:t>
-            </a:r>
-          </a:p>
-        </p:txBody>
-      </p:sp>
-      <p:sp>
-        <p:nvSpPr>
-          <p:cNvPr id="11" name="Rounded Rectangle 10"/>
-          <p:cNvSpPr/>
-          <p:nvPr/>
-        </p:nvSpPr>
-        <p:spPr>
-          <a:xfrm>
-            <a:off x="8321040" y="2880360"/>
-            <a:ext cx="3246120" cy="2011680"/>
-          </a:xfrm>
-          <a:prstGeom prst="roundRect">
-            <a:avLst/>
-          </a:prstGeom>
-          <a:solidFill>
-            <a:srgbClr val="FFFFFF"/>
-          </a:solidFill>
-          <a:ln>
-            <a:solidFill>
-              <a:srgbClr val="57B8E8"/>
-            </a:solidFill>
-          </a:ln>
-        </p:spPr>
-        <p:style>
-          <a:lnRef idx="1">
-            <a:schemeClr val="accent1"/>
-          </a:lnRef>
-          <a:fillRef idx="3">
-            <a:schemeClr val="accent1"/>
-          </a:fillRef>
-          <a:effectRef idx="2">
-            <a:schemeClr val="accent1"/>
-          </a:effectRef>
-          <a:fontRef idx="minor">
-            <a:schemeClr val="lt1"/>
-          </a:fontRef>
-        </p:style>
-        <p:txBody>
-          <a:bodyPr rtlCol="0" anchor="ctr"/>
-          <a:lstStyle/>
-          <a:p>
-            <a:pPr algn="ctr"/>
-          </a:p>
-        </p:txBody>
-      </p:sp>
-      <p:sp>
-        <p:nvSpPr>
-          <p:cNvPr id="12" name="TextBox 11"/>
-          <p:cNvSpPr txBox="1"/>
-          <p:nvPr/>
-        </p:nvSpPr>
-        <p:spPr>
-          <a:xfrm>
-            <a:off x="8485632" y="3108960"/>
-            <a:ext cx="2834640" cy="292608"/>
-          </a:xfrm>
-          <a:prstGeom prst="rect">
-            <a:avLst/>
-          </a:prstGeom>
-          <a:noFill/>
-        </p:spPr>
-        <p:txBody>
-          <a:bodyPr wrap="square" anchor="t">
-            <a:spAutoFit/>
-          </a:bodyPr>
-          <a:lstStyle/>
-          <a:p>
-            <a:pPr algn="l">
-              <a:lnSpc>
-                <a:spcPct val="120000"/>
-              </a:lnSpc>
-              <a:defRPr sz="1900" b="1">
-                <a:solidFill>
-                  <a:srgbClr val="57D6FF"/>
-                </a:solidFill>
-                <a:latin typeface="Aptos"/>
-              </a:defRPr>
-            </a:pPr>
-            <a:r>
-              <a:t>Bewertung</a:t>
-            </a:r>
-          </a:p>
-        </p:txBody>
-      </p:sp>
-      <p:sp>
-        <p:nvSpPr>
-          <p:cNvPr id="13" name="TextBox 12"/>
-          <p:cNvSpPr txBox="1"/>
-          <p:nvPr/>
-        </p:nvSpPr>
-        <p:spPr>
-          <a:xfrm>
-            <a:off x="8485632" y="3493008"/>
-            <a:ext cx="2880360" cy="1005840"/>
-          </a:xfrm>
-          <a:prstGeom prst="rect">
-            <a:avLst/>
-          </a:prstGeom>
-          <a:noFill/>
-        </p:spPr>
-        <p:txBody>
-          <a:bodyPr wrap="square" anchor="t">
-            <a:spAutoFit/>
-          </a:bodyPr>
-          <a:lstStyle/>
-          <a:p>
-            <a:pPr algn="l">
-              <a:lnSpc>
-                <a:spcPct val="120000"/>
-              </a:lnSpc>
-              <a:defRPr sz="1400" b="0">
-                <a:solidFill>
-                  <a:srgbClr val="E2ECF4"/>
-                </a:solidFill>
-                <a:latin typeface="Aptos"/>
-              </a:defRPr>
-            </a:pPr>
-            <a:r>
-              <a:t>Wegen Quecksilber, Schaltverhalten und LED-Fortschritt sinkt ihre Bedeutung.</a:t>
-            </a:r>
-          </a:p>
-        </p:txBody>
-      </p:sp>
-      <p:sp>
-        <p:nvSpPr>
-          <p:cNvPr id="14" name="TextBox 13"/>
-          <p:cNvSpPr txBox="1"/>
-          <p:nvPr/>
-        </p:nvSpPr>
-        <p:spPr>
-          <a:xfrm>
-            <a:off x="3337560" y="5669280"/>
-            <a:ext cx="5486400" cy="320040"/>
-          </a:xfrm>
-          <a:prstGeom prst="rect">
-            <a:avLst/>
-          </a:prstGeom>
-          <a:noFill/>
-        </p:spPr>
-        <p:txBody>
-          <a:bodyPr wrap="square" anchor="t">
-            <a:spAutoFit/>
-          </a:bodyPr>
-          <a:lstStyle/>
-          <a:p>
-            <a:pPr algn="ctr">
-              <a:lnSpc>
-                <a:spcPct val="120000"/>
-              </a:lnSpc>
-              <a:defRPr sz="1700" b="1">
-                <a:solidFill>
-                  <a:srgbClr val="B8D0E2"/>
-                </a:solidFill>
-                <a:latin typeface="Aptos"/>
-              </a:defRPr>
-            </a:pPr>
-            <a:r>
-              <a:t>Danke für eure Aufmerksamkeit</a:t>
-            </a:r>
-          </a:p>
-        </p:txBody>
-      </p:sp>
-    </p:spTree>
-  </p:cSld>
-  <p:clrMapOvr>
-    <a:masterClrMapping/>
-  </p:clrMapOvr>
-</p:sld>
-</file>
-
-<file path=ppt/slides/slide2.xml><?xml version="1.0" encoding="utf-8"?>
-<p:sld xmlns:a="http://schemas.openxmlformats.org/drawingml/2006/main" xmlns:p="http://schemas.openxmlformats.org/presentationml/2006/main" xmlns:r="http://schemas.openxmlformats.org/officeDocument/2006/relationships">
-  <p:cSld>
-    <p:bg>
-      <p:bgPr>
-        <a:solidFill>
-          <a:srgbClr val="F6F8FB"/>
-        </a:solidFill>
-        <a:effectLst/>
-      </p:bgPr>
-    </p:bg>
-    <p:spTree>
-      <p:nvGrpSpPr>
-        <p:cNvPr id="1" name=""/>
-        <p:cNvGrpSpPr/>
-        <p:nvPr/>
-      </p:nvGrpSpPr>
-      <p:grpSpPr/>
-      <p:sp>
-        <p:nvSpPr>
-          <p:cNvPr id="2" name="TextBox 1"/>
-          <p:cNvSpPr txBox="1"/>
-          <p:nvPr/>
-        </p:nvSpPr>
-        <p:spPr>
-          <a:xfrm>
-            <a:off x="640080" y="411480"/>
-            <a:ext cx="9601200" cy="548640"/>
-          </a:xfrm>
-          <a:prstGeom prst="rect">
-            <a:avLst/>
-          </a:prstGeom>
-          <a:noFill/>
-        </p:spPr>
-        <p:txBody>
-          <a:bodyPr wrap="square" anchor="t">
-            <a:spAutoFit/>
-          </a:bodyPr>
-          <a:lstStyle/>
-          <a:p>
-            <a:pPr algn="l">
-              <a:lnSpc>
-                <a:spcPct val="120000"/>
-              </a:lnSpc>
-              <a:defRPr sz="2500" b="1">
-                <a:solidFill>
-                  <a:srgbClr val="142C48"/>
-                </a:solidFill>
-                <a:latin typeface="Aptos Display"/>
-              </a:defRPr>
-            </a:pPr>
-            <a:r>
-              <a:t>Warum ist die Leuchtstofflampe im Berufsalltag wichtig?</a:t>
-            </a:r>
-          </a:p>
-        </p:txBody>
-      </p:sp>
-      <p:sp>
-        <p:nvSpPr>
-          <p:cNvPr id="3" name="TextBox 2"/>
-          <p:cNvSpPr txBox="1"/>
-          <p:nvPr/>
-        </p:nvSpPr>
-        <p:spPr>
-          <a:xfrm>
-            <a:off x="658368" y="868680"/>
-            <a:ext cx="9875520" cy="320040"/>
-          </a:xfrm>
-          <a:prstGeom prst="rect">
-            <a:avLst/>
-          </a:prstGeom>
-          <a:noFill/>
-        </p:spPr>
-        <p:txBody>
-          <a:bodyPr wrap="square" anchor="t">
-            <a:spAutoFit/>
-          </a:bodyPr>
-          <a:lstStyle/>
-          <a:p>
-            <a:pPr algn="l">
-              <a:lnSpc>
-                <a:spcPct val="120000"/>
-              </a:lnSpc>
-              <a:defRPr sz="1200" b="0">
-                <a:solidFill>
-                  <a:srgbClr val="63707C"/>
-                </a:solidFill>
-                <a:latin typeface="Aptos"/>
-              </a:defRPr>
-            </a:pPr>
-            <a:r>
-              <a:t>Einordnung für Elektrotechnik, Beleuchtungstechnik und Gebäudepraxis</a:t>
-            </a:r>
-          </a:p>
-        </p:txBody>
-      </p:sp>
-      <p:sp>
-        <p:nvSpPr>
-          <p:cNvPr id="4" name="Rounded Rectangle 3"/>
-          <p:cNvSpPr/>
-          <p:nvPr/>
-        </p:nvSpPr>
-        <p:spPr>
-          <a:xfrm>
-            <a:off x="731520" y="1554480"/>
-            <a:ext cx="3474720" cy="1874519"/>
-          </a:xfrm>
-          <a:prstGeom prst="roundRect">
-            <a:avLst/>
-          </a:prstGeom>
-          <a:solidFill>
-            <a:srgbClr val="FFFFFF"/>
-          </a:solidFill>
-          <a:ln>
-            <a:solidFill>
-              <a:srgbClr val="E0E7ED"/>
-            </a:solidFill>
-          </a:ln>
-        </p:spPr>
-        <p:style>
-          <a:lnRef idx="1">
-            <a:schemeClr val="accent1"/>
-          </a:lnRef>
-          <a:fillRef idx="3">
-            <a:schemeClr val="accent1"/>
-          </a:fillRef>
-          <a:effectRef idx="2">
-            <a:schemeClr val="accent1"/>
-          </a:effectRef>
-          <a:fontRef idx="minor">
-            <a:schemeClr val="lt1"/>
-          </a:fontRef>
-        </p:style>
-        <p:txBody>
-          <a:bodyPr rtlCol="0" anchor="ctr"/>
-          <a:lstStyle/>
-          <a:p>
-            <a:pPr algn="ctr"/>
-          </a:p>
-        </p:txBody>
-      </p:sp>
-      <p:sp>
-        <p:nvSpPr>
-          <p:cNvPr id="5" name="TextBox 4"/>
-          <p:cNvSpPr txBox="1"/>
-          <p:nvPr/>
-        </p:nvSpPr>
-        <p:spPr>
-          <a:xfrm>
-            <a:off x="932688" y="1719072"/>
-            <a:ext cx="3154680" cy="384048"/>
-          </a:xfrm>
-          <a:prstGeom prst="rect">
-            <a:avLst/>
-          </a:prstGeom>
-          <a:noFill/>
-        </p:spPr>
-        <p:txBody>
-          <a:bodyPr wrap="square" anchor="t">
-            <a:spAutoFit/>
-          </a:bodyPr>
-          <a:lstStyle/>
-          <a:p>
-            <a:pPr algn="l">
-              <a:lnSpc>
-                <a:spcPct val="120000"/>
-              </a:lnSpc>
-              <a:defRPr sz="1800" b="1">
-                <a:solidFill>
-                  <a:srgbClr val="142C48"/>
-                </a:solidFill>
-                <a:latin typeface="Aptos"/>
-              </a:defRPr>
-            </a:pPr>
-            <a:r>
-              <a:t>Technischer Kern</a:t>
-            </a:r>
-          </a:p>
-        </p:txBody>
-      </p:sp>
-      <p:sp>
-        <p:nvSpPr>
-          <p:cNvPr id="6" name="TextBox 5"/>
-          <p:cNvSpPr txBox="1"/>
-          <p:nvPr/>
-        </p:nvSpPr>
-        <p:spPr>
-          <a:xfrm>
-            <a:off x="932688" y="2084832"/>
-            <a:ext cx="3154680" cy="1188719"/>
-          </a:xfrm>
-          <a:prstGeom prst="rect">
-            <a:avLst/>
-          </a:prstGeom>
-          <a:noFill/>
-        </p:spPr>
-        <p:txBody>
-          <a:bodyPr wrap="square" anchor="t">
-            <a:spAutoFit/>
-          </a:bodyPr>
-          <a:lstStyle/>
-          <a:p>
-            <a:pPr algn="l">
-              <a:lnSpc>
-                <a:spcPct val="120000"/>
-              </a:lnSpc>
-              <a:defRPr sz="1300" b="0">
-                <a:solidFill>
-                  <a:srgbClr val="485461"/>
-                </a:solidFill>
-                <a:latin typeface="Aptos"/>
-              </a:defRPr>
-            </a:pPr>
-            <a:r>
-              <a:t>Sie gehört zu den Gasentladungslampen. Das sichtbare Licht entsteht erst über die Leuchtstoffschicht im Inneren.</a:t>
-            </a:r>
-          </a:p>
-        </p:txBody>
-      </p:sp>
-      <p:sp>
-        <p:nvSpPr>
-          <p:cNvPr id="7" name="Rounded Rectangle 6"/>
-          <p:cNvSpPr/>
-          <p:nvPr/>
-        </p:nvSpPr>
-        <p:spPr>
-          <a:xfrm>
-            <a:off x="4361688" y="1554480"/>
-            <a:ext cx="3474720" cy="1874519"/>
-          </a:xfrm>
-          <a:prstGeom prst="roundRect">
-            <a:avLst/>
-          </a:prstGeom>
-          <a:solidFill>
-            <a:srgbClr val="FFFFFF"/>
-          </a:solidFill>
-          <a:ln>
-            <a:solidFill>
-              <a:srgbClr val="E0E7ED"/>
-            </a:solidFill>
-          </a:ln>
-        </p:spPr>
-        <p:style>
-          <a:lnRef idx="1">
-            <a:schemeClr val="accent1"/>
-          </a:lnRef>
-          <a:fillRef idx="3">
-            <a:schemeClr val="accent1"/>
-          </a:fillRef>
-          <a:effectRef idx="2">
-            <a:schemeClr val="accent1"/>
-          </a:effectRef>
-          <a:fontRef idx="minor">
-            <a:schemeClr val="lt1"/>
-          </a:fontRef>
-        </p:style>
-        <p:txBody>
-          <a:bodyPr rtlCol="0" anchor="ctr"/>
-          <a:lstStyle/>
-          <a:p>
-            <a:pPr algn="ctr"/>
-          </a:p>
-        </p:txBody>
-      </p:sp>
-      <p:sp>
-        <p:nvSpPr>
-          <p:cNvPr id="8" name="TextBox 7"/>
-          <p:cNvSpPr txBox="1"/>
-          <p:nvPr/>
-        </p:nvSpPr>
-        <p:spPr>
-          <a:xfrm>
-            <a:off x="4562856" y="1719072"/>
-            <a:ext cx="3154680" cy="384048"/>
-          </a:xfrm>
-          <a:prstGeom prst="rect">
-            <a:avLst/>
-          </a:prstGeom>
-          <a:noFill/>
-        </p:spPr>
-        <p:txBody>
-          <a:bodyPr wrap="square" anchor="t">
-            <a:spAutoFit/>
-          </a:bodyPr>
-          <a:lstStyle/>
-          <a:p>
-            <a:pPr algn="l">
-              <a:lnSpc>
-                <a:spcPct val="120000"/>
-              </a:lnSpc>
-              <a:defRPr sz="1800" b="1">
-                <a:solidFill>
-                  <a:srgbClr val="142C48"/>
-                </a:solidFill>
-                <a:latin typeface="Aptos"/>
-              </a:defRPr>
-            </a:pPr>
-            <a:r>
-              <a:t>Praxisbezug</a:t>
-            </a:r>
-          </a:p>
-        </p:txBody>
-      </p:sp>
-      <p:sp>
-        <p:nvSpPr>
-          <p:cNvPr id="9" name="TextBox 8"/>
-          <p:cNvSpPr txBox="1"/>
-          <p:nvPr/>
-        </p:nvSpPr>
-        <p:spPr>
-          <a:xfrm>
-            <a:off x="4562856" y="2084832"/>
-            <a:ext cx="3154680" cy="1188719"/>
-          </a:xfrm>
-          <a:prstGeom prst="rect">
-            <a:avLst/>
-          </a:prstGeom>
-          <a:noFill/>
-        </p:spPr>
-        <p:txBody>
-          <a:bodyPr wrap="square" anchor="t">
-            <a:spAutoFit/>
-          </a:bodyPr>
-          <a:lstStyle/>
-          <a:p>
-            <a:pPr algn="l">
-              <a:lnSpc>
-                <a:spcPct val="120000"/>
-              </a:lnSpc>
-              <a:defRPr sz="1300" b="0">
-                <a:solidFill>
-                  <a:srgbClr val="485461"/>
-                </a:solidFill>
-                <a:latin typeface="Aptos"/>
-              </a:defRPr>
-            </a:pPr>
-            <a:r>
-              <a:t>In Schulen, Büros und Werkhallen war diese Lampenart lange Standard, weil sie große Räume wirtschaftlich ausleuchtet.</a:t>
-            </a:r>
-          </a:p>
-        </p:txBody>
-      </p:sp>
-      <p:sp>
-        <p:nvSpPr>
-          <p:cNvPr id="10" name="Rounded Rectangle 9"/>
-          <p:cNvSpPr/>
-          <p:nvPr/>
-        </p:nvSpPr>
-        <p:spPr>
-          <a:xfrm>
-            <a:off x="7991856" y="1554480"/>
-            <a:ext cx="3474720" cy="1874519"/>
-          </a:xfrm>
-          <a:prstGeom prst="roundRect">
-            <a:avLst/>
-          </a:prstGeom>
-          <a:solidFill>
-            <a:srgbClr val="FFFFFF"/>
-          </a:solidFill>
-          <a:ln>
-            <a:solidFill>
-              <a:srgbClr val="E0E7ED"/>
-            </a:solidFill>
-          </a:ln>
-        </p:spPr>
-        <p:style>
-          <a:lnRef idx="1">
-            <a:schemeClr val="accent1"/>
-          </a:lnRef>
-          <a:fillRef idx="3">
-            <a:schemeClr val="accent1"/>
-          </a:fillRef>
-          <a:effectRef idx="2">
-            <a:schemeClr val="accent1"/>
-          </a:effectRef>
-          <a:fontRef idx="minor">
-            <a:schemeClr val="lt1"/>
-          </a:fontRef>
-        </p:style>
-        <p:txBody>
-          <a:bodyPr rtlCol="0" anchor="ctr"/>
-          <a:lstStyle/>
-          <a:p>
-            <a:pPr algn="ctr"/>
-          </a:p>
-        </p:txBody>
-      </p:sp>
-      <p:sp>
-        <p:nvSpPr>
-          <p:cNvPr id="11" name="TextBox 10"/>
-          <p:cNvSpPr txBox="1"/>
-          <p:nvPr/>
-        </p:nvSpPr>
-        <p:spPr>
-          <a:xfrm>
-            <a:off x="8193024" y="1719072"/>
-            <a:ext cx="3154680" cy="384048"/>
-          </a:xfrm>
-          <a:prstGeom prst="rect">
-            <a:avLst/>
-          </a:prstGeom>
-          <a:noFill/>
-        </p:spPr>
-        <p:txBody>
-          <a:bodyPr wrap="square" anchor="t">
-            <a:spAutoFit/>
-          </a:bodyPr>
-          <a:lstStyle/>
-          <a:p>
-            <a:pPr algn="l">
-              <a:lnSpc>
-                <a:spcPct val="120000"/>
-              </a:lnSpc>
-              <a:defRPr sz="1800" b="1">
-                <a:solidFill>
-                  <a:srgbClr val="142C48"/>
-                </a:solidFill>
-                <a:latin typeface="Aptos"/>
-              </a:defRPr>
-            </a:pPr>
-            <a:r>
-              <a:t>Heute relevant, weil …</a:t>
-            </a:r>
-          </a:p>
-        </p:txBody>
-      </p:sp>
-      <p:sp>
-        <p:nvSpPr>
-          <p:cNvPr id="12" name="TextBox 11"/>
-          <p:cNvSpPr txBox="1"/>
-          <p:nvPr/>
-        </p:nvSpPr>
-        <p:spPr>
-          <a:xfrm>
-            <a:off x="8193024" y="2084832"/>
-            <a:ext cx="3154680" cy="1188719"/>
-          </a:xfrm>
-          <a:prstGeom prst="rect">
-            <a:avLst/>
-          </a:prstGeom>
-          <a:noFill/>
-        </p:spPr>
-        <p:txBody>
-          <a:bodyPr wrap="square" anchor="t">
-            <a:spAutoFit/>
-          </a:bodyPr>
-          <a:lstStyle/>
-          <a:p>
-            <a:pPr algn="l">
-              <a:lnSpc>
-                <a:spcPct val="120000"/>
-              </a:lnSpc>
-              <a:defRPr sz="1300" b="0">
-                <a:solidFill>
-                  <a:srgbClr val="485461"/>
-                </a:solidFill>
-                <a:latin typeface="Aptos"/>
-              </a:defRPr>
-            </a:pPr>
-            <a:r>
-              <a:t>… Bestandsanlagen weiterhin existieren und der Vergleich mit moderner LED-Technik in der Berufsschule wichtig ist.</a:t>
-            </a:r>
-          </a:p>
-        </p:txBody>
-      </p:sp>
-      <p:sp>
-        <p:nvSpPr>
-          <p:cNvPr id="13" name="TextBox 12"/>
-          <p:cNvSpPr txBox="1"/>
-          <p:nvPr/>
-        </p:nvSpPr>
-        <p:spPr>
-          <a:xfrm>
-            <a:off x="868680" y="3886200"/>
-            <a:ext cx="5212080" cy="1737360"/>
-          </a:xfrm>
-          <a:prstGeom prst="rect">
-            <a:avLst/>
-          </a:prstGeom>
-          <a:noFill/>
-        </p:spPr>
-        <p:txBody>
-          <a:bodyPr wrap="square" anchor="t">
-            <a:spAutoFit/>
-          </a:bodyPr>
-          <a:lstStyle/>
-          <a:p>
-            <a:pPr algn="l">
-              <a:lnSpc>
-                <a:spcPct val="120000"/>
-              </a:lnSpc>
-              <a:defRPr sz="1700" b="0">
-                <a:solidFill>
-                  <a:srgbClr val="364351"/>
-                </a:solidFill>
-                <a:latin typeface="Aptos"/>
-              </a:defRPr>
-            </a:pPr>
-            <a:r>
-              <a:t>Diese Präsentation behandelt genau die Punkte aus dem Arbeitsauftrag:</a:t>
-            </a:r>
-          </a:p>
-          <a:p>
-            <a:pPr>
-              <a:lnSpc>
-                <a:spcPct val="120000"/>
-              </a:lnSpc>
-              <a:defRPr sz="1700" b="0">
-                <a:solidFill>
-                  <a:srgbClr val="364351"/>
-                </a:solidFill>
-                <a:latin typeface="Aptos"/>
-              </a:defRPr>
-            </a:pPr>
-          </a:p>
-          <a:p>
-            <a:pPr>
-              <a:lnSpc>
-                <a:spcPct val="120000"/>
-              </a:lnSpc>
-              <a:defRPr sz="1700" b="0">
-                <a:solidFill>
-                  <a:srgbClr val="364351"/>
-                </a:solidFill>
-                <a:latin typeface="Aptos"/>
-              </a:defRPr>
-            </a:pPr>
-            <a:r>
-              <a:t>Aufbau, Funktionsweise, Betriebsverhalten, Bauformen, Lichtfarben, Besonderheiten und typische Einsatzbereiche.</a:t>
-            </a:r>
-          </a:p>
-        </p:txBody>
-      </p:sp>
-      <p:sp>
-        <p:nvSpPr>
-          <p:cNvPr id="14" name="Rounded Rectangle 13"/>
-          <p:cNvSpPr/>
-          <p:nvPr/>
-        </p:nvSpPr>
-        <p:spPr>
-          <a:xfrm>
-            <a:off x="6629400" y="3822191"/>
-            <a:ext cx="4846320" cy="1783080"/>
-          </a:xfrm>
-          <a:prstGeom prst="roundRect">
-            <a:avLst/>
-          </a:prstGeom>
-          <a:solidFill>
-            <a:srgbClr val="185C97"/>
-          </a:solidFill>
-          <a:ln>
-            <a:solidFill>
-              <a:srgbClr val="185C97"/>
-            </a:solidFill>
-          </a:ln>
-        </p:spPr>
-        <p:style>
-          <a:lnRef idx="1">
-            <a:schemeClr val="accent1"/>
-          </a:lnRef>
-          <a:fillRef idx="3">
-            <a:schemeClr val="accent1"/>
-          </a:fillRef>
-          <a:effectRef idx="2">
-            <a:schemeClr val="accent1"/>
-          </a:effectRef>
-          <a:fontRef idx="minor">
-            <a:schemeClr val="lt1"/>
-          </a:fontRef>
-        </p:style>
-        <p:txBody>
-          <a:bodyPr rtlCol="0" anchor="ctr"/>
-          <a:lstStyle/>
-          <a:p>
-            <a:pPr algn="ctr"/>
-          </a:p>
-        </p:txBody>
-      </p:sp>
-      <p:sp>
-        <p:nvSpPr>
-          <p:cNvPr id="15" name="TextBox 14"/>
-          <p:cNvSpPr txBox="1"/>
-          <p:nvPr/>
-        </p:nvSpPr>
-        <p:spPr>
-          <a:xfrm>
-            <a:off x="6903720" y="4114800"/>
-            <a:ext cx="4297680" cy="1234440"/>
-          </a:xfrm>
-          <a:prstGeom prst="rect">
-            <a:avLst/>
-          </a:prstGeom>
-          <a:noFill/>
-        </p:spPr>
-        <p:txBody>
-          <a:bodyPr wrap="square" anchor="t">
-            <a:spAutoFit/>
-          </a:bodyPr>
-          <a:lstStyle/>
-          <a:p>
-            <a:pPr algn="l">
-              <a:lnSpc>
-                <a:spcPct val="120000"/>
-              </a:lnSpc>
-              <a:defRPr sz="1800" b="0">
-                <a:solidFill>
-                  <a:srgbClr val="FFFFFF"/>
-                </a:solidFill>
-                <a:latin typeface="Aptos"/>
-              </a:defRPr>
-            </a:pPr>
-            <a:r>
-              <a:t>Merksatz:</a:t>
-            </a:r>
-          </a:p>
-          <a:p>
-            <a:pPr>
-              <a:lnSpc>
-                <a:spcPct val="120000"/>
-              </a:lnSpc>
-              <a:defRPr sz="1800" b="0">
-                <a:solidFill>
-                  <a:srgbClr val="FFFFFF"/>
-                </a:solidFill>
-                <a:latin typeface="Aptos"/>
-              </a:defRPr>
-            </a:pPr>
-            <a:r>
-              <a:t>Leuchtstofflampen sind effizienter als Glühlampen, aber in vielen Bereichen bereits von LEDs verdrängt.</a:t>
-            </a:r>
-          </a:p>
-        </p:txBody>
-      </p:sp>
-    </p:spTree>
-  </p:cSld>
-  <p:clrMapOvr>
-    <a:masterClrMapping/>
-  </p:clrMapOvr>
-</p:sld>
-</file>
-
-<file path=ppt/slides/slide3.xml><?xml version="1.0" encoding="utf-8"?>
-<p:sld xmlns:a="http://schemas.openxmlformats.org/drawingml/2006/main" xmlns:p="http://schemas.openxmlformats.org/presentationml/2006/main" xmlns:r="http://schemas.openxmlformats.org/officeDocument/2006/relationships">
-  <p:cSld>
-    <p:bg>
-      <p:bgPr>
-        <a:solidFill>
-          <a:srgbClr val="F9FBFD"/>
-        </a:solidFill>
-        <a:effectLst/>
-      </p:bgPr>
-    </p:bg>
-    <p:spTree>
-      <p:nvGrpSpPr>
-        <p:cNvPr id="1" name=""/>
-        <p:cNvGrpSpPr/>
-        <p:nvPr/>
-      </p:nvGrpSpPr>
-      <p:grpSpPr/>
-      <p:sp>
-        <p:nvSpPr>
-          <p:cNvPr id="2" name="TextBox 1"/>
-          <p:cNvSpPr txBox="1"/>
-          <p:nvPr/>
-        </p:nvSpPr>
-        <p:spPr>
-          <a:xfrm>
-            <a:off x="640080" y="411480"/>
-            <a:ext cx="9601200" cy="548640"/>
-          </a:xfrm>
-          <a:prstGeom prst="rect">
-            <a:avLst/>
-          </a:prstGeom>
-          <a:noFill/>
-        </p:spPr>
-        <p:txBody>
-          <a:bodyPr wrap="square" anchor="t">
-            <a:spAutoFit/>
-          </a:bodyPr>
-          <a:lstStyle/>
-          <a:p>
-            <a:pPr algn="l">
-              <a:lnSpc>
-                <a:spcPct val="120000"/>
-              </a:lnSpc>
-              <a:defRPr sz="2500" b="1">
-                <a:solidFill>
-                  <a:srgbClr val="142C48"/>
-                </a:solidFill>
-                <a:latin typeface="Aptos Display"/>
-              </a:defRPr>
-            </a:pPr>
-            <a:r>
-              <a:t>Aufbau einer Leuchtstofflampe</a:t>
-            </a:r>
-          </a:p>
-        </p:txBody>
-      </p:sp>
-      <p:sp>
-        <p:nvSpPr>
-          <p:cNvPr id="3" name="TextBox 2"/>
-          <p:cNvSpPr txBox="1"/>
-          <p:nvPr/>
-        </p:nvSpPr>
-        <p:spPr>
-          <a:xfrm>
-            <a:off x="658368" y="868680"/>
-            <a:ext cx="9875520" cy="320040"/>
-          </a:xfrm>
-          <a:prstGeom prst="rect">
-            <a:avLst/>
-          </a:prstGeom>
-          <a:noFill/>
-        </p:spPr>
-        <p:txBody>
-          <a:bodyPr wrap="square" anchor="t">
-            <a:spAutoFit/>
-          </a:bodyPr>
-          <a:lstStyle/>
-          <a:p>
-            <a:pPr algn="l">
-              <a:lnSpc>
-                <a:spcPct val="120000"/>
-              </a:lnSpc>
-              <a:defRPr sz="1200" b="0">
-                <a:solidFill>
-                  <a:srgbClr val="63707C"/>
-                </a:solidFill>
-                <a:latin typeface="Aptos"/>
-              </a:defRPr>
-            </a:pPr>
-            <a:r>
-              <a:t>Die wichtigsten Bauteile in einer übersichtlichen technischen Darstellung</a:t>
-            </a:r>
-          </a:p>
-        </p:txBody>
-      </p:sp>
       <p:pic>
         <p:nvPicPr>
-          <p:cNvPr id="4" name="Picture 3" descr="tech_cutaway.png"/>
+          <p:cNvPr id="2" name="Picture 1" descr="slide10.jpg"/>
           <p:cNvPicPr>
             <a:picLocks noChangeAspect="1"/>
           </p:cNvPicPr>
@@ -4496,132 +3155,14 @@
         </p:blipFill>
         <p:spPr>
           <a:xfrm>
-            <a:off x="384048" y="1298448"/>
-            <a:ext cx="7406640" cy="4892040"/>
+            <a:off x="0" y="0"/>
+            <a:ext cx="12191695" cy="6858000"/>
           </a:xfrm>
           <a:prstGeom prst="rect">
             <a:avLst/>
           </a:prstGeom>
         </p:spPr>
       </p:pic>
-      <p:sp>
-        <p:nvSpPr>
-          <p:cNvPr id="5" name="TextBox 4"/>
-          <p:cNvSpPr txBox="1"/>
-          <p:nvPr/>
-        </p:nvSpPr>
-        <p:spPr>
-          <a:xfrm>
-            <a:off x="8138160" y="1600200"/>
-            <a:ext cx="3383280" cy="2286000"/>
-          </a:xfrm>
-          <a:prstGeom prst="rect">
-            <a:avLst/>
-          </a:prstGeom>
-          <a:noFill/>
-        </p:spPr>
-        <p:txBody>
-          <a:bodyPr wrap="square">
-            <a:spAutoFit/>
-          </a:bodyPr>
-          <a:lstStyle/>
-          <a:p>
-            <a:pPr>
-              <a:lnSpc>
-                <a:spcPct val="115000"/>
-              </a:lnSpc>
-              <a:spcAft>
-                <a:spcPts val="400"/>
-              </a:spcAft>
-              <a:defRPr sz="1500">
-                <a:solidFill>
-                  <a:srgbClr val="3C4854"/>
-                </a:solidFill>
-                <a:latin typeface="Aptos"/>
-              </a:defRPr>
-            </a:pPr>
-            <a:r>
-              <a:t>• Glasrohr schützt die Komponenten und führt die Entladung.</a:t>
-            </a:r>
-          </a:p>
-          <a:p>
-            <a:pPr>
-              <a:lnSpc>
-                <a:spcPct val="115000"/>
-              </a:lnSpc>
-              <a:spcAft>
-                <a:spcPts val="400"/>
-              </a:spcAft>
-              <a:defRPr sz="1500">
-                <a:solidFill>
-                  <a:srgbClr val="3C4854"/>
-                </a:solidFill>
-                <a:latin typeface="Aptos"/>
-              </a:defRPr>
-            </a:pPr>
-            <a:r>
-              <a:t>• Elektroden an den Enden zünden die Lampe beim Start.</a:t>
-            </a:r>
-          </a:p>
-          <a:p>
-            <a:pPr>
-              <a:lnSpc>
-                <a:spcPct val="115000"/>
-              </a:lnSpc>
-              <a:spcAft>
-                <a:spcPts val="400"/>
-              </a:spcAft>
-              <a:defRPr sz="1500">
-                <a:solidFill>
-                  <a:srgbClr val="3C4854"/>
-                </a:solidFill>
-                <a:latin typeface="Aptos"/>
-              </a:defRPr>
-            </a:pPr>
-            <a:r>
-              <a:t>• Edelgas und Quecksilberdampf erzeugen UV-Strahlung.</a:t>
-            </a:r>
-          </a:p>
-          <a:p>
-            <a:pPr>
-              <a:lnSpc>
-                <a:spcPct val="115000"/>
-              </a:lnSpc>
-              <a:spcAft>
-                <a:spcPts val="400"/>
-              </a:spcAft>
-              <a:defRPr sz="1500">
-                <a:solidFill>
-                  <a:srgbClr val="3C4854"/>
-                </a:solidFill>
-                <a:latin typeface="Aptos"/>
-              </a:defRPr>
-            </a:pPr>
-            <a:r>
-              <a:t>• Die Leuchtstoffschicht wandelt UV in sichtbares Licht um.</a:t>
-            </a:r>
-          </a:p>
-          <a:p>
-            <a:pPr>
-              <a:lnSpc>
-                <a:spcPct val="115000"/>
-              </a:lnSpc>
-              <a:spcAft>
-                <a:spcPts val="400"/>
-              </a:spcAft>
-              <a:defRPr sz="1500">
-                <a:solidFill>
-                  <a:srgbClr val="3C4854"/>
-                </a:solidFill>
-                <a:latin typeface="Aptos"/>
-              </a:defRPr>
-            </a:pPr>
-            <a:r>
-              <a:t>• Ein Vorschaltgerät begrenzt den Strom im Betrieb.</a:t>
-            </a:r>
-          </a:p>
-        </p:txBody>
-      </p:sp>
     </p:spTree>
   </p:cSld>
   <p:clrMapOvr>
@@ -4630,17 +3171,9 @@
 </p:sld>
 </file>
 
-<file path=ppt/slides/slide4.xml><?xml version="1.0" encoding="utf-8"?>
+<file path=ppt/slides/slide2.xml><?xml version="1.0" encoding="utf-8"?>
 <p:sld xmlns:a="http://schemas.openxmlformats.org/drawingml/2006/main" xmlns:p="http://schemas.openxmlformats.org/presentationml/2006/main" xmlns:r="http://schemas.openxmlformats.org/officeDocument/2006/relationships">
   <p:cSld>
-    <p:bg>
-      <p:bgPr>
-        <a:solidFill>
-          <a:srgbClr val="F4F8FB"/>
-        </a:solidFill>
-        <a:effectLst/>
-      </p:bgPr>
-    </p:bg>
     <p:spTree>
       <p:nvGrpSpPr>
         <p:cNvPr id="1" name=""/>
@@ -4648,87 +3181,9 @@
         <p:nvPr/>
       </p:nvGrpSpPr>
       <p:grpSpPr/>
-      <p:sp>
-        <p:nvSpPr>
-          <p:cNvPr id="2" name="TextBox 1"/>
-          <p:cNvSpPr txBox="1"/>
-          <p:nvPr/>
-        </p:nvSpPr>
-        <p:spPr>
-          <a:xfrm>
-            <a:off x="640080" y="411480"/>
-            <a:ext cx="9601200" cy="548640"/>
-          </a:xfrm>
-          <a:prstGeom prst="rect">
-            <a:avLst/>
-          </a:prstGeom>
-          <a:noFill/>
-        </p:spPr>
-        <p:txBody>
-          <a:bodyPr wrap="square" anchor="t">
-            <a:spAutoFit/>
-          </a:bodyPr>
-          <a:lstStyle/>
-          <a:p>
-            <a:pPr algn="l">
-              <a:lnSpc>
-                <a:spcPct val="120000"/>
-              </a:lnSpc>
-              <a:defRPr sz="2500" b="1">
-                <a:solidFill>
-                  <a:srgbClr val="142C48"/>
-                </a:solidFill>
-                <a:latin typeface="Aptos Display"/>
-              </a:defRPr>
-            </a:pPr>
-            <a:r>
-              <a:t>Funktionsweise Schritt für Schritt</a:t>
-            </a:r>
-          </a:p>
-        </p:txBody>
-      </p:sp>
-      <p:sp>
-        <p:nvSpPr>
-          <p:cNvPr id="3" name="TextBox 2"/>
-          <p:cNvSpPr txBox="1"/>
-          <p:nvPr/>
-        </p:nvSpPr>
-        <p:spPr>
-          <a:xfrm>
-            <a:off x="658368" y="868680"/>
-            <a:ext cx="9875520" cy="320040"/>
-          </a:xfrm>
-          <a:prstGeom prst="rect">
-            <a:avLst/>
-          </a:prstGeom>
-          <a:noFill/>
-        </p:spPr>
-        <p:txBody>
-          <a:bodyPr wrap="square" anchor="t">
-            <a:spAutoFit/>
-          </a:bodyPr>
-          <a:lstStyle/>
-          <a:p>
-            <a:pPr algn="l">
-              <a:lnSpc>
-                <a:spcPct val="120000"/>
-              </a:lnSpc>
-              <a:defRPr sz="1200" b="0">
-                <a:solidFill>
-                  <a:srgbClr val="63707C"/>
-                </a:solidFill>
-                <a:latin typeface="Aptos"/>
-              </a:defRPr>
-            </a:pPr>
-            <a:r>
-              <a:t>Vom Einschalten bis zur gleichmäßigen Lichtabgabe</a:t>
-            </a:r>
-          </a:p>
-        </p:txBody>
-      </p:sp>
       <p:pic>
         <p:nvPicPr>
-          <p:cNvPr id="4" name="Picture 3" descr="function_flow.png"/>
+          <p:cNvPr id="2" name="Picture 1" descr="slide2.jpg"/>
           <p:cNvPicPr>
             <a:picLocks noChangeAspect="1"/>
           </p:cNvPicPr>
@@ -4742,8 +3197,92 @@
         </p:blipFill>
         <p:spPr>
           <a:xfrm>
-            <a:off x="320040" y="1353312"/>
-            <a:ext cx="11567160" cy="4846320"/>
+            <a:off x="0" y="0"/>
+            <a:ext cx="12191695" cy="6858000"/>
+          </a:xfrm>
+          <a:prstGeom prst="rect">
+            <a:avLst/>
+          </a:prstGeom>
+        </p:spPr>
+      </p:pic>
+    </p:spTree>
+  </p:cSld>
+  <p:clrMapOvr>
+    <a:masterClrMapping/>
+  </p:clrMapOvr>
+</p:sld>
+</file>
+
+<file path=ppt/slides/slide3.xml><?xml version="1.0" encoding="utf-8"?>
+<p:sld xmlns:a="http://schemas.openxmlformats.org/drawingml/2006/main" xmlns:p="http://schemas.openxmlformats.org/presentationml/2006/main" xmlns:r="http://schemas.openxmlformats.org/officeDocument/2006/relationships">
+  <p:cSld>
+    <p:spTree>
+      <p:nvGrpSpPr>
+        <p:cNvPr id="1" name=""/>
+        <p:cNvGrpSpPr/>
+        <p:nvPr/>
+      </p:nvGrpSpPr>
+      <p:grpSpPr/>
+      <p:pic>
+        <p:nvPicPr>
+          <p:cNvPr id="2" name="Picture 1" descr="slide3.jpg"/>
+          <p:cNvPicPr>
+            <a:picLocks noChangeAspect="1"/>
+          </p:cNvPicPr>
+          <p:nvPr/>
+        </p:nvPicPr>
+        <p:blipFill>
+          <a:blip r:embed="rId2"/>
+          <a:stretch>
+            <a:fillRect/>
+          </a:stretch>
+        </p:blipFill>
+        <p:spPr>
+          <a:xfrm>
+            <a:off x="0" y="0"/>
+            <a:ext cx="12191695" cy="6858000"/>
+          </a:xfrm>
+          <a:prstGeom prst="rect">
+            <a:avLst/>
+          </a:prstGeom>
+        </p:spPr>
+      </p:pic>
+    </p:spTree>
+  </p:cSld>
+  <p:clrMapOvr>
+    <a:masterClrMapping/>
+  </p:clrMapOvr>
+</p:sld>
+</file>
+
+<file path=ppt/slides/slide4.xml><?xml version="1.0" encoding="utf-8"?>
+<p:sld xmlns:a="http://schemas.openxmlformats.org/drawingml/2006/main" xmlns:p="http://schemas.openxmlformats.org/presentationml/2006/main" xmlns:r="http://schemas.openxmlformats.org/officeDocument/2006/relationships">
+  <p:cSld>
+    <p:spTree>
+      <p:nvGrpSpPr>
+        <p:cNvPr id="1" name=""/>
+        <p:cNvGrpSpPr/>
+        <p:nvPr/>
+      </p:nvGrpSpPr>
+      <p:grpSpPr/>
+      <p:pic>
+        <p:nvPicPr>
+          <p:cNvPr id="2" name="Picture 1" descr="slide4.jpg"/>
+          <p:cNvPicPr>
+            <a:picLocks noChangeAspect="1"/>
+          </p:cNvPicPr>
+          <p:nvPr/>
+        </p:nvPicPr>
+        <p:blipFill>
+          <a:blip r:embed="rId2"/>
+          <a:stretch>
+            <a:fillRect/>
+          </a:stretch>
+        </p:blipFill>
+        <p:spPr>
+          <a:xfrm>
+            <a:off x="0" y="0"/>
+            <a:ext cx="12191695" cy="6858000"/>
           </a:xfrm>
           <a:prstGeom prst="rect">
             <a:avLst/>
@@ -4761,14 +3300,6 @@
 <file path=ppt/slides/slide5.xml><?xml version="1.0" encoding="utf-8"?>
 <p:sld xmlns:a="http://schemas.openxmlformats.org/drawingml/2006/main" xmlns:p="http://schemas.openxmlformats.org/presentationml/2006/main" xmlns:r="http://schemas.openxmlformats.org/officeDocument/2006/relationships">
   <p:cSld>
-    <p:bg>
-      <p:bgPr>
-        <a:solidFill>
-          <a:srgbClr val="F7F9FB"/>
-        </a:solidFill>
-        <a:effectLst/>
-      </p:bgPr>
-    </p:bg>
     <p:spTree>
       <p:nvGrpSpPr>
         <p:cNvPr id="1" name=""/>
@@ -4776,87 +3307,9 @@
         <p:nvPr/>
       </p:nvGrpSpPr>
       <p:grpSpPr/>
-      <p:sp>
-        <p:nvSpPr>
-          <p:cNvPr id="2" name="TextBox 1"/>
-          <p:cNvSpPr txBox="1"/>
-          <p:nvPr/>
-        </p:nvSpPr>
-        <p:spPr>
-          <a:xfrm>
-            <a:off x="640080" y="411480"/>
-            <a:ext cx="9601200" cy="548640"/>
-          </a:xfrm>
-          <a:prstGeom prst="rect">
-            <a:avLst/>
-          </a:prstGeom>
-          <a:noFill/>
-        </p:spPr>
-        <p:txBody>
-          <a:bodyPr wrap="square" anchor="t">
-            <a:spAutoFit/>
-          </a:bodyPr>
-          <a:lstStyle/>
-          <a:p>
-            <a:pPr algn="l">
-              <a:lnSpc>
-                <a:spcPct val="120000"/>
-              </a:lnSpc>
-              <a:defRPr sz="2500" b="1">
-                <a:solidFill>
-                  <a:srgbClr val="142C48"/>
-                </a:solidFill>
-                <a:latin typeface="Aptos Display"/>
-              </a:defRPr>
-            </a:pPr>
-            <a:r>
-              <a:t>Betriebsverhalten und typische Kennwerte</a:t>
-            </a:r>
-          </a:p>
-        </p:txBody>
-      </p:sp>
-      <p:sp>
-        <p:nvSpPr>
-          <p:cNvPr id="3" name="TextBox 2"/>
-          <p:cNvSpPr txBox="1"/>
-          <p:nvPr/>
-        </p:nvSpPr>
-        <p:spPr>
-          <a:xfrm>
-            <a:off x="658368" y="868680"/>
-            <a:ext cx="9875520" cy="320040"/>
-          </a:xfrm>
-          <a:prstGeom prst="rect">
-            <a:avLst/>
-          </a:prstGeom>
-          <a:noFill/>
-        </p:spPr>
-        <p:txBody>
-          <a:bodyPr wrap="square" anchor="t">
-            <a:spAutoFit/>
-          </a:bodyPr>
-          <a:lstStyle/>
-          <a:p>
-            <a:pPr algn="l">
-              <a:lnSpc>
-                <a:spcPct val="120000"/>
-              </a:lnSpc>
-              <a:defRPr sz="1200" b="0">
-                <a:solidFill>
-                  <a:srgbClr val="63707C"/>
-                </a:solidFill>
-                <a:latin typeface="Aptos"/>
-              </a:defRPr>
-            </a:pPr>
-            <a:r>
-              <a:t>Worauf man im praktischen Einsatz achten muss</a:t>
-            </a:r>
-          </a:p>
-        </p:txBody>
-      </p:sp>
       <p:pic>
         <p:nvPicPr>
-          <p:cNvPr id="4" name="Picture 3" descr="behavior_panel.png"/>
+          <p:cNvPr id="2" name="Picture 1" descr="slide5.jpg"/>
           <p:cNvPicPr>
             <a:picLocks noChangeAspect="1"/>
           </p:cNvPicPr>
@@ -4870,8 +3323,8 @@
         </p:blipFill>
         <p:spPr>
           <a:xfrm>
-            <a:off x="228600" y="1234440"/>
-            <a:ext cx="11750040" cy="5074920"/>
+            <a:off x="0" y="0"/>
+            <a:ext cx="12191695" cy="6858000"/>
           </a:xfrm>
           <a:prstGeom prst="rect">
             <a:avLst/>
@@ -4889,14 +3342,6 @@
 <file path=ppt/slides/slide6.xml><?xml version="1.0" encoding="utf-8"?>
 <p:sld xmlns:a="http://schemas.openxmlformats.org/drawingml/2006/main" xmlns:p="http://schemas.openxmlformats.org/presentationml/2006/main" xmlns:r="http://schemas.openxmlformats.org/officeDocument/2006/relationships">
   <p:cSld>
-    <p:bg>
-      <p:bgPr>
-        <a:solidFill>
-          <a:srgbClr val="F5F8FB"/>
-        </a:solidFill>
-        <a:effectLst/>
-      </p:bgPr>
-    </p:bg>
     <p:spTree>
       <p:nvGrpSpPr>
         <p:cNvPr id="1" name=""/>
@@ -4904,87 +3349,9 @@
         <p:nvPr/>
       </p:nvGrpSpPr>
       <p:grpSpPr/>
-      <p:sp>
-        <p:nvSpPr>
-          <p:cNvPr id="2" name="TextBox 1"/>
-          <p:cNvSpPr txBox="1"/>
-          <p:nvPr/>
-        </p:nvSpPr>
-        <p:spPr>
-          <a:xfrm>
-            <a:off x="640080" y="411480"/>
-            <a:ext cx="9601200" cy="548640"/>
-          </a:xfrm>
-          <a:prstGeom prst="rect">
-            <a:avLst/>
-          </a:prstGeom>
-          <a:noFill/>
-        </p:spPr>
-        <p:txBody>
-          <a:bodyPr wrap="square" anchor="t">
-            <a:spAutoFit/>
-          </a:bodyPr>
-          <a:lstStyle/>
-          <a:p>
-            <a:pPr algn="l">
-              <a:lnSpc>
-                <a:spcPct val="120000"/>
-              </a:lnSpc>
-              <a:defRPr sz="2500" b="1">
-                <a:solidFill>
-                  <a:srgbClr val="142C48"/>
-                </a:solidFill>
-                <a:latin typeface="Aptos Display"/>
-              </a:defRPr>
-            </a:pPr>
-            <a:r>
-              <a:t>Bauformen, Ausführungen und Farbtemperaturen</a:t>
-            </a:r>
-          </a:p>
-        </p:txBody>
-      </p:sp>
-      <p:sp>
-        <p:nvSpPr>
-          <p:cNvPr id="3" name="TextBox 2"/>
-          <p:cNvSpPr txBox="1"/>
-          <p:nvPr/>
-        </p:nvSpPr>
-        <p:spPr>
-          <a:xfrm>
-            <a:off x="658368" y="868680"/>
-            <a:ext cx="9875520" cy="320040"/>
-          </a:xfrm>
-          <a:prstGeom prst="rect">
-            <a:avLst/>
-          </a:prstGeom>
-          <a:noFill/>
-        </p:spPr>
-        <p:txBody>
-          <a:bodyPr wrap="square" anchor="t">
-            <a:spAutoFit/>
-          </a:bodyPr>
-          <a:lstStyle/>
-          <a:p>
-            <a:pPr algn="l">
-              <a:lnSpc>
-                <a:spcPct val="120000"/>
-              </a:lnSpc>
-              <a:defRPr sz="1200" b="0">
-                <a:solidFill>
-                  <a:srgbClr val="63707C"/>
-                </a:solidFill>
-                <a:latin typeface="Aptos"/>
-              </a:defRPr>
-            </a:pPr>
-            <a:r>
-              <a:t>Die Auswahl richtet sich nach Leuchte, Raum und Arbeitsaufgabe</a:t>
-            </a:r>
-          </a:p>
-        </p:txBody>
-      </p:sp>
       <p:pic>
         <p:nvPicPr>
-          <p:cNvPr id="4" name="Picture 3" descr="forms_colors.png"/>
+          <p:cNvPr id="2" name="Picture 1" descr="slide6.jpg"/>
           <p:cNvPicPr>
             <a:picLocks noChangeAspect="1"/>
           </p:cNvPicPr>
@@ -4998,8 +3365,8 @@
         </p:blipFill>
         <p:spPr>
           <a:xfrm>
-            <a:off x="320040" y="1307592"/>
-            <a:ext cx="11567160" cy="4828032"/>
+            <a:off x="0" y="0"/>
+            <a:ext cx="12191695" cy="6858000"/>
           </a:xfrm>
           <a:prstGeom prst="rect">
             <a:avLst/>
@@ -5017,14 +3384,6 @@
 <file path=ppt/slides/slide7.xml><?xml version="1.0" encoding="utf-8"?>
 <p:sld xmlns:a="http://schemas.openxmlformats.org/drawingml/2006/main" xmlns:p="http://schemas.openxmlformats.org/presentationml/2006/main" xmlns:r="http://schemas.openxmlformats.org/officeDocument/2006/relationships">
   <p:cSld>
-    <p:bg>
-      <p:bgPr>
-        <a:solidFill>
-          <a:srgbClr val="121F31"/>
-        </a:solidFill>
-        <a:effectLst/>
-      </p:bgPr>
-    </p:bg>
     <p:spTree>
       <p:nvGrpSpPr>
         <p:cNvPr id="1" name=""/>
@@ -5032,87 +3391,9 @@
         <p:nvPr/>
       </p:nvGrpSpPr>
       <p:grpSpPr/>
-      <p:sp>
-        <p:nvSpPr>
-          <p:cNvPr id="2" name="TextBox 1"/>
-          <p:cNvSpPr txBox="1"/>
-          <p:nvPr/>
-        </p:nvSpPr>
-        <p:spPr>
-          <a:xfrm>
-            <a:off x="640080" y="411480"/>
-            <a:ext cx="9601200" cy="548640"/>
-          </a:xfrm>
-          <a:prstGeom prst="rect">
-            <a:avLst/>
-          </a:prstGeom>
-          <a:noFill/>
-        </p:spPr>
-        <p:txBody>
-          <a:bodyPr wrap="square" anchor="t">
-            <a:spAutoFit/>
-          </a:bodyPr>
-          <a:lstStyle/>
-          <a:p>
-            <a:pPr algn="l">
-              <a:lnSpc>
-                <a:spcPct val="120000"/>
-              </a:lnSpc>
-              <a:defRPr sz="2500" b="1">
-                <a:solidFill>
-                  <a:srgbClr val="FFFFFF"/>
-                </a:solidFill>
-                <a:latin typeface="Aptos Display"/>
-              </a:defRPr>
-            </a:pPr>
-            <a:r>
-              <a:t>Typische Anwendungsbereiche</a:t>
-            </a:r>
-          </a:p>
-        </p:txBody>
-      </p:sp>
-      <p:sp>
-        <p:nvSpPr>
-          <p:cNvPr id="3" name="TextBox 2"/>
-          <p:cNvSpPr txBox="1"/>
-          <p:nvPr/>
-        </p:nvSpPr>
-        <p:spPr>
-          <a:xfrm>
-            <a:off x="658368" y="868680"/>
-            <a:ext cx="9875520" cy="320040"/>
-          </a:xfrm>
-          <a:prstGeom prst="rect">
-            <a:avLst/>
-          </a:prstGeom>
-          <a:noFill/>
-        </p:spPr>
-        <p:txBody>
-          <a:bodyPr wrap="square" anchor="t">
-            <a:spAutoFit/>
-          </a:bodyPr>
-          <a:lstStyle/>
-          <a:p>
-            <a:pPr algn="l">
-              <a:lnSpc>
-                <a:spcPct val="120000"/>
-              </a:lnSpc>
-              <a:defRPr sz="1200" b="0">
-                <a:solidFill>
-                  <a:srgbClr val="D6E3ED"/>
-                </a:solidFill>
-                <a:latin typeface="Aptos"/>
-              </a:defRPr>
-            </a:pPr>
-            <a:r>
-              <a:t>Beispiele aus Schule, Büro, Werkstatt und Lagerhalle</a:t>
-            </a:r>
-          </a:p>
-        </p:txBody>
-      </p:sp>
       <p:pic>
         <p:nvPicPr>
-          <p:cNvPr id="4" name="Picture 3" descr="applications.png"/>
+          <p:cNvPr id="2" name="Picture 1" descr="slide7.jpg"/>
           <p:cNvPicPr>
             <a:picLocks noChangeAspect="1"/>
           </p:cNvPicPr>
@@ -5126,8 +3407,8 @@
         </p:blipFill>
         <p:spPr>
           <a:xfrm>
-            <a:off x="201168" y="1234440"/>
-            <a:ext cx="11795760" cy="5138928"/>
+            <a:off x="0" y="0"/>
+            <a:ext cx="12191695" cy="6858000"/>
           </a:xfrm>
           <a:prstGeom prst="rect">
             <a:avLst/>
@@ -5145,14 +3426,6 @@
 <file path=ppt/slides/slide8.xml><?xml version="1.0" encoding="utf-8"?>
 <p:sld xmlns:a="http://schemas.openxmlformats.org/drawingml/2006/main" xmlns:p="http://schemas.openxmlformats.org/presentationml/2006/main" xmlns:r="http://schemas.openxmlformats.org/officeDocument/2006/relationships">
   <p:cSld>
-    <p:bg>
-      <p:bgPr>
-        <a:solidFill>
-          <a:srgbClr val="F7F9FC"/>
-        </a:solidFill>
-        <a:effectLst/>
-      </p:bgPr>
-    </p:bg>
     <p:spTree>
       <p:nvGrpSpPr>
         <p:cNvPr id="1" name=""/>
@@ -5160,557 +3433,9 @@
         <p:nvPr/>
       </p:nvGrpSpPr>
       <p:grpSpPr/>
-      <p:sp>
-        <p:nvSpPr>
-          <p:cNvPr id="2" name="TextBox 1"/>
-          <p:cNvSpPr txBox="1"/>
-          <p:nvPr/>
-        </p:nvSpPr>
-        <p:spPr>
-          <a:xfrm>
-            <a:off x="640080" y="411480"/>
-            <a:ext cx="9601200" cy="548640"/>
-          </a:xfrm>
-          <a:prstGeom prst="rect">
-            <a:avLst/>
-          </a:prstGeom>
-          <a:noFill/>
-        </p:spPr>
-        <p:txBody>
-          <a:bodyPr wrap="square" anchor="t">
-            <a:spAutoFit/>
-          </a:bodyPr>
-          <a:lstStyle/>
-          <a:p>
-            <a:pPr algn="l">
-              <a:lnSpc>
-                <a:spcPct val="120000"/>
-              </a:lnSpc>
-              <a:defRPr sz="2500" b="1">
-                <a:solidFill>
-                  <a:srgbClr val="142C48"/>
-                </a:solidFill>
-                <a:latin typeface="Aptos Display"/>
-              </a:defRPr>
-            </a:pPr>
-            <a:r>
-              <a:t>Vorteile und Grenzen</a:t>
-            </a:r>
-          </a:p>
-        </p:txBody>
-      </p:sp>
-      <p:sp>
-        <p:nvSpPr>
-          <p:cNvPr id="3" name="TextBox 2"/>
-          <p:cNvSpPr txBox="1"/>
-          <p:nvPr/>
-        </p:nvSpPr>
-        <p:spPr>
-          <a:xfrm>
-            <a:off x="658368" y="868680"/>
-            <a:ext cx="9875520" cy="320040"/>
-          </a:xfrm>
-          <a:prstGeom prst="rect">
-            <a:avLst/>
-          </a:prstGeom>
-          <a:noFill/>
-        </p:spPr>
-        <p:txBody>
-          <a:bodyPr wrap="square" anchor="t">
-            <a:spAutoFit/>
-          </a:bodyPr>
-          <a:lstStyle/>
-          <a:p>
-            <a:pPr algn="l">
-              <a:lnSpc>
-                <a:spcPct val="120000"/>
-              </a:lnSpc>
-              <a:defRPr sz="1200" b="0">
-                <a:solidFill>
-                  <a:srgbClr val="63707C"/>
-                </a:solidFill>
-                <a:latin typeface="Aptos"/>
-              </a:defRPr>
-            </a:pPr>
-            <a:r>
-              <a:t>Die Technik ist nachvollziehbar stark – hat aber klare Nachteile gegenüber LED</a:t>
-            </a:r>
-          </a:p>
-        </p:txBody>
-      </p:sp>
-      <p:sp>
-        <p:nvSpPr>
-          <p:cNvPr id="4" name="Rounded Rectangle 3"/>
-          <p:cNvSpPr/>
-          <p:nvPr/>
-        </p:nvSpPr>
-        <p:spPr>
-          <a:xfrm>
-            <a:off x="822960" y="1572768"/>
-            <a:ext cx="5074920" cy="4434840"/>
-          </a:xfrm>
-          <a:prstGeom prst="roundRect">
-            <a:avLst/>
-          </a:prstGeom>
-          <a:solidFill>
-            <a:srgbClr val="FFFFFF"/>
-          </a:solidFill>
-          <a:ln>
-            <a:solidFill>
-              <a:srgbClr val="43AB74"/>
-            </a:solidFill>
-          </a:ln>
-        </p:spPr>
-        <p:style>
-          <a:lnRef idx="1">
-            <a:schemeClr val="accent1"/>
-          </a:lnRef>
-          <a:fillRef idx="3">
-            <a:schemeClr val="accent1"/>
-          </a:fillRef>
-          <a:effectRef idx="2">
-            <a:schemeClr val="accent1"/>
-          </a:effectRef>
-          <a:fontRef idx="minor">
-            <a:schemeClr val="lt1"/>
-          </a:fontRef>
-        </p:style>
-        <p:txBody>
-          <a:bodyPr rtlCol="0" anchor="ctr"/>
-          <a:lstStyle/>
-          <a:p>
-            <a:pPr algn="ctr"/>
-          </a:p>
-        </p:txBody>
-      </p:sp>
-      <p:sp>
-        <p:nvSpPr>
-          <p:cNvPr id="5" name="Rounded Rectangle 4"/>
-          <p:cNvSpPr/>
-          <p:nvPr/>
-        </p:nvSpPr>
-        <p:spPr>
-          <a:xfrm>
-            <a:off x="6263640" y="1572768"/>
-            <a:ext cx="5074920" cy="4434840"/>
-          </a:xfrm>
-          <a:prstGeom prst="roundRect">
-            <a:avLst/>
-          </a:prstGeom>
-          <a:solidFill>
-            <a:srgbClr val="FFFFFF"/>
-          </a:solidFill>
-          <a:ln>
-            <a:solidFill>
-              <a:srgbClr val="D65F5F"/>
-            </a:solidFill>
-          </a:ln>
-        </p:spPr>
-        <p:style>
-          <a:lnRef idx="1">
-            <a:schemeClr val="accent1"/>
-          </a:lnRef>
-          <a:fillRef idx="3">
-            <a:schemeClr val="accent1"/>
-          </a:fillRef>
-          <a:effectRef idx="2">
-            <a:schemeClr val="accent1"/>
-          </a:effectRef>
-          <a:fontRef idx="minor">
-            <a:schemeClr val="lt1"/>
-          </a:fontRef>
-        </p:style>
-        <p:txBody>
-          <a:bodyPr rtlCol="0" anchor="ctr"/>
-          <a:lstStyle/>
-          <a:p>
-            <a:pPr algn="ctr"/>
-          </a:p>
-        </p:txBody>
-      </p:sp>
-      <p:sp>
-        <p:nvSpPr>
-          <p:cNvPr id="6" name="TextBox 5"/>
-          <p:cNvSpPr txBox="1"/>
-          <p:nvPr/>
-        </p:nvSpPr>
-        <p:spPr>
-          <a:xfrm>
-            <a:off x="1097280" y="1828800"/>
-            <a:ext cx="2194560" cy="320040"/>
-          </a:xfrm>
-          <a:prstGeom prst="rect">
-            <a:avLst/>
-          </a:prstGeom>
-          <a:noFill/>
-        </p:spPr>
-        <p:txBody>
-          <a:bodyPr wrap="square" anchor="t">
-            <a:spAutoFit/>
-          </a:bodyPr>
-          <a:lstStyle/>
-          <a:p>
-            <a:pPr algn="l">
-              <a:lnSpc>
-                <a:spcPct val="120000"/>
-              </a:lnSpc>
-              <a:defRPr sz="2300" b="1">
-                <a:solidFill>
-                  <a:srgbClr val="43AB74"/>
-                </a:solidFill>
-                <a:latin typeface="Aptos"/>
-              </a:defRPr>
-            </a:pPr>
-            <a:r>
-              <a:t>Vorteile</a:t>
-            </a:r>
-          </a:p>
-        </p:txBody>
-      </p:sp>
-      <p:sp>
-        <p:nvSpPr>
-          <p:cNvPr id="7" name="TextBox 6"/>
-          <p:cNvSpPr txBox="1"/>
-          <p:nvPr/>
-        </p:nvSpPr>
-        <p:spPr>
-          <a:xfrm>
-            <a:off x="1078992" y="2240280"/>
-            <a:ext cx="4389120" cy="1865376"/>
-          </a:xfrm>
-          <a:prstGeom prst="rect">
-            <a:avLst/>
-          </a:prstGeom>
-          <a:noFill/>
-        </p:spPr>
-        <p:txBody>
-          <a:bodyPr wrap="square">
-            <a:spAutoFit/>
-          </a:bodyPr>
-          <a:lstStyle/>
-          <a:p>
-            <a:pPr>
-              <a:lnSpc>
-                <a:spcPct val="115000"/>
-              </a:lnSpc>
-              <a:spcAft>
-                <a:spcPts val="400"/>
-              </a:spcAft>
-              <a:defRPr sz="1600">
-                <a:solidFill>
-                  <a:srgbClr val="3C4854"/>
-                </a:solidFill>
-                <a:latin typeface="Aptos"/>
-              </a:defRPr>
-            </a:pPr>
-            <a:r>
-              <a:t>• gute Lichtausbeute gegenüber klassischen Glühlampen</a:t>
-            </a:r>
-          </a:p>
-          <a:p>
-            <a:pPr>
-              <a:lnSpc>
-                <a:spcPct val="115000"/>
-              </a:lnSpc>
-              <a:spcAft>
-                <a:spcPts val="400"/>
-              </a:spcAft>
-              <a:defRPr sz="1600">
-                <a:solidFill>
-                  <a:srgbClr val="3C4854"/>
-                </a:solidFill>
-                <a:latin typeface="Aptos"/>
-              </a:defRPr>
-            </a:pPr>
-            <a:r>
-              <a:t>• gleichmäßige und breite Ausleuchtung</a:t>
-            </a:r>
-          </a:p>
-          <a:p>
-            <a:pPr>
-              <a:lnSpc>
-                <a:spcPct val="115000"/>
-              </a:lnSpc>
-              <a:spcAft>
-                <a:spcPts val="400"/>
-              </a:spcAft>
-              <a:defRPr sz="1600">
-                <a:solidFill>
-                  <a:srgbClr val="3C4854"/>
-                </a:solidFill>
-                <a:latin typeface="Aptos"/>
-              </a:defRPr>
-            </a:pPr>
-            <a:r>
-              <a:t>• verschiedene Lichtfarben möglich</a:t>
-            </a:r>
-          </a:p>
-          <a:p>
-            <a:pPr>
-              <a:lnSpc>
-                <a:spcPct val="115000"/>
-              </a:lnSpc>
-              <a:spcAft>
-                <a:spcPts val="400"/>
-              </a:spcAft>
-              <a:defRPr sz="1600">
-                <a:solidFill>
-                  <a:srgbClr val="3C4854"/>
-                </a:solidFill>
-                <a:latin typeface="Aptos"/>
-              </a:defRPr>
-            </a:pPr>
-            <a:r>
-              <a:t>• für große Räume lange wirtschaftlich sinnvoll</a:t>
-            </a:r>
-          </a:p>
-        </p:txBody>
-      </p:sp>
-      <p:sp>
-        <p:nvSpPr>
-          <p:cNvPr id="8" name="TextBox 7"/>
-          <p:cNvSpPr txBox="1"/>
-          <p:nvPr/>
-        </p:nvSpPr>
-        <p:spPr>
-          <a:xfrm>
-            <a:off x="6537960" y="1828800"/>
-            <a:ext cx="2377440" cy="320040"/>
-          </a:xfrm>
-          <a:prstGeom prst="rect">
-            <a:avLst/>
-          </a:prstGeom>
-          <a:noFill/>
-        </p:spPr>
-        <p:txBody>
-          <a:bodyPr wrap="square" anchor="t">
-            <a:spAutoFit/>
-          </a:bodyPr>
-          <a:lstStyle/>
-          <a:p>
-            <a:pPr algn="l">
-              <a:lnSpc>
-                <a:spcPct val="120000"/>
-              </a:lnSpc>
-              <a:defRPr sz="2300" b="1">
-                <a:solidFill>
-                  <a:srgbClr val="D65F5F"/>
-                </a:solidFill>
-                <a:latin typeface="Aptos"/>
-              </a:defRPr>
-            </a:pPr>
-            <a:r>
-              <a:t>Nachteile</a:t>
-            </a:r>
-          </a:p>
-        </p:txBody>
-      </p:sp>
-      <p:sp>
-        <p:nvSpPr>
-          <p:cNvPr id="9" name="TextBox 8"/>
-          <p:cNvSpPr txBox="1"/>
-          <p:nvPr/>
-        </p:nvSpPr>
-        <p:spPr>
-          <a:xfrm>
-            <a:off x="6519672" y="2240280"/>
-            <a:ext cx="4389120" cy="1865376"/>
-          </a:xfrm>
-          <a:prstGeom prst="rect">
-            <a:avLst/>
-          </a:prstGeom>
-          <a:noFill/>
-        </p:spPr>
-        <p:txBody>
-          <a:bodyPr wrap="square">
-            <a:spAutoFit/>
-          </a:bodyPr>
-          <a:lstStyle/>
-          <a:p>
-            <a:pPr>
-              <a:lnSpc>
-                <a:spcPct val="115000"/>
-              </a:lnSpc>
-              <a:spcAft>
-                <a:spcPts val="400"/>
-              </a:spcAft>
-              <a:defRPr sz="1600">
-                <a:solidFill>
-                  <a:srgbClr val="3C4854"/>
-                </a:solidFill>
-                <a:latin typeface="Aptos"/>
-              </a:defRPr>
-            </a:pPr>
-            <a:r>
-              <a:t>• enthält Quecksilber und ist damit entsorgungspflichtig</a:t>
-            </a:r>
-          </a:p>
-          <a:p>
-            <a:pPr>
-              <a:lnSpc>
-                <a:spcPct val="115000"/>
-              </a:lnSpc>
-              <a:spcAft>
-                <a:spcPts val="400"/>
-              </a:spcAft>
-              <a:defRPr sz="1600">
-                <a:solidFill>
-                  <a:srgbClr val="3C4854"/>
-                </a:solidFill>
-                <a:latin typeface="Aptos"/>
-              </a:defRPr>
-            </a:pPr>
-            <a:r>
-              <a:t>• braucht oft kurze Anlaufzeit bis zur vollen Helligkeit</a:t>
-            </a:r>
-          </a:p>
-          <a:p>
-            <a:pPr>
-              <a:lnSpc>
-                <a:spcPct val="115000"/>
-              </a:lnSpc>
-              <a:spcAft>
-                <a:spcPts val="400"/>
-              </a:spcAft>
-              <a:defRPr sz="1600">
-                <a:solidFill>
-                  <a:srgbClr val="3C4854"/>
-                </a:solidFill>
-                <a:latin typeface="Aptos"/>
-              </a:defRPr>
-            </a:pPr>
-            <a:r>
-              <a:t>• häufiges Schalten verkürzt die Lebensdauer</a:t>
-            </a:r>
-          </a:p>
-          <a:p>
-            <a:pPr>
-              <a:lnSpc>
-                <a:spcPct val="115000"/>
-              </a:lnSpc>
-              <a:spcAft>
-                <a:spcPts val="400"/>
-              </a:spcAft>
-              <a:defRPr sz="1600">
-                <a:solidFill>
-                  <a:srgbClr val="3C4854"/>
-                </a:solidFill>
-                <a:latin typeface="Aptos"/>
-              </a:defRPr>
-            </a:pPr>
-            <a:r>
-              <a:t>• heute in vielen Bereichen technisch von LEDs übertroffen</a:t>
-            </a:r>
-          </a:p>
-        </p:txBody>
-      </p:sp>
-    </p:spTree>
-  </p:cSld>
-  <p:clrMapOvr>
-    <a:masterClrMapping/>
-  </p:clrMapOvr>
-</p:sld>
-</file>
-
-<file path=ppt/slides/slide9.xml><?xml version="1.0" encoding="utf-8"?>
-<p:sld xmlns:a="http://schemas.openxmlformats.org/drawingml/2006/main" xmlns:p="http://schemas.openxmlformats.org/presentationml/2006/main" xmlns:r="http://schemas.openxmlformats.org/officeDocument/2006/relationships">
-  <p:cSld>
-    <p:bg>
-      <p:bgPr>
-        <a:solidFill>
-          <a:srgbClr val="F6F8F7"/>
-        </a:solidFill>
-        <a:effectLst/>
-      </p:bgPr>
-    </p:bg>
-    <p:spTree>
-      <p:nvGrpSpPr>
-        <p:cNvPr id="1" name=""/>
-        <p:cNvGrpSpPr/>
-        <p:nvPr/>
-      </p:nvGrpSpPr>
-      <p:grpSpPr/>
-      <p:sp>
-        <p:nvSpPr>
-          <p:cNvPr id="2" name="TextBox 1"/>
-          <p:cNvSpPr txBox="1"/>
-          <p:nvPr/>
-        </p:nvSpPr>
-        <p:spPr>
-          <a:xfrm>
-            <a:off x="640080" y="411480"/>
-            <a:ext cx="9601200" cy="548640"/>
-          </a:xfrm>
-          <a:prstGeom prst="rect">
-            <a:avLst/>
-          </a:prstGeom>
-          <a:noFill/>
-        </p:spPr>
-        <p:txBody>
-          <a:bodyPr wrap="square" anchor="t">
-            <a:spAutoFit/>
-          </a:bodyPr>
-          <a:lstStyle/>
-          <a:p>
-            <a:pPr algn="l">
-              <a:lnSpc>
-                <a:spcPct val="120000"/>
-              </a:lnSpc>
-              <a:defRPr sz="2500" b="1">
-                <a:solidFill>
-                  <a:srgbClr val="142C48"/>
-                </a:solidFill>
-                <a:latin typeface="Aptos Display"/>
-              </a:defRPr>
-            </a:pPr>
-            <a:r>
-              <a:t>Besonderheiten: Umwelt, Entsorgung und heutige Bedeutung</a:t>
-            </a:r>
-          </a:p>
-        </p:txBody>
-      </p:sp>
-      <p:sp>
-        <p:nvSpPr>
-          <p:cNvPr id="3" name="TextBox 2"/>
-          <p:cNvSpPr txBox="1"/>
-          <p:nvPr/>
-        </p:nvSpPr>
-        <p:spPr>
-          <a:xfrm>
-            <a:off x="658368" y="868680"/>
-            <a:ext cx="9875520" cy="320040"/>
-          </a:xfrm>
-          <a:prstGeom prst="rect">
-            <a:avLst/>
-          </a:prstGeom>
-          <a:noFill/>
-        </p:spPr>
-        <p:txBody>
-          <a:bodyPr wrap="square" anchor="t">
-            <a:spAutoFit/>
-          </a:bodyPr>
-          <a:lstStyle/>
-          <a:p>
-            <a:pPr algn="l">
-              <a:lnSpc>
-                <a:spcPct val="120000"/>
-              </a:lnSpc>
-              <a:defRPr sz="1200" b="0">
-                <a:solidFill>
-                  <a:srgbClr val="63707C"/>
-                </a:solidFill>
-                <a:latin typeface="Aptos"/>
-              </a:defRPr>
-            </a:pPr>
-            <a:r>
-              <a:t>Wichtige Hinweise für den sicheren und fachgerechten Umgang</a:t>
-            </a:r>
-          </a:p>
-        </p:txBody>
-      </p:sp>
       <p:pic>
         <p:nvPicPr>
-          <p:cNvPr id="4" name="Picture 3" descr="environment.png"/>
+          <p:cNvPr id="2" name="Picture 1" descr="slide8.jpg"/>
           <p:cNvPicPr>
             <a:picLocks noChangeAspect="1"/>
           </p:cNvPicPr>
@@ -5724,8 +3449,50 @@
         </p:blipFill>
         <p:spPr>
           <a:xfrm>
-            <a:off x="274320" y="1316736"/>
-            <a:ext cx="11658600" cy="4892040"/>
+            <a:off x="0" y="0"/>
+            <a:ext cx="12191695" cy="6858000"/>
+          </a:xfrm>
+          <a:prstGeom prst="rect">
+            <a:avLst/>
+          </a:prstGeom>
+        </p:spPr>
+      </p:pic>
+    </p:spTree>
+  </p:cSld>
+  <p:clrMapOvr>
+    <a:masterClrMapping/>
+  </p:clrMapOvr>
+</p:sld>
+</file>
+
+<file path=ppt/slides/slide9.xml><?xml version="1.0" encoding="utf-8"?>
+<p:sld xmlns:a="http://schemas.openxmlformats.org/drawingml/2006/main" xmlns:p="http://schemas.openxmlformats.org/presentationml/2006/main" xmlns:r="http://schemas.openxmlformats.org/officeDocument/2006/relationships">
+  <p:cSld>
+    <p:spTree>
+      <p:nvGrpSpPr>
+        <p:cNvPr id="1" name=""/>
+        <p:cNvGrpSpPr/>
+        <p:nvPr/>
+      </p:nvGrpSpPr>
+      <p:grpSpPr/>
+      <p:pic>
+        <p:nvPicPr>
+          <p:cNvPr id="2" name="Picture 1" descr="slide9.jpg"/>
+          <p:cNvPicPr>
+            <a:picLocks noChangeAspect="1"/>
+          </p:cNvPicPr>
+          <p:nvPr/>
+        </p:nvPicPr>
+        <p:blipFill>
+          <a:blip r:embed="rId2"/>
+          <a:stretch>
+            <a:fillRect/>
+          </a:stretch>
+        </p:blipFill>
+        <p:spPr>
+          <a:xfrm>
+            <a:off x="0" y="0"/>
+            <a:ext cx="12191695" cy="6858000"/>
           </a:xfrm>
           <a:prstGeom prst="rect">
             <a:avLst/>

</xml_diff>